<commit_message>
Data Wrangling 2026: update SQL test slides
</commit_message>
<xml_diff>
--- a/testing/test_sql.pptx
+++ b/testing/test_sql.pptx
@@ -5,27 +5,30 @@
     <p:sldMasterId id="2147483648" r:id="rId1"/>
   </p:sldMasterIdLst>
   <p:notesMasterIdLst>
-    <p:notesMasterId r:id="rId20"/>
+    <p:notesMasterId r:id="rId23"/>
   </p:notesMasterIdLst>
   <p:sldIdLst>
     <p:sldId id="256" r:id="rId2"/>
     <p:sldId id="257" r:id="rId3"/>
-    <p:sldId id="258" r:id="rId4"/>
-    <p:sldId id="260" r:id="rId5"/>
-    <p:sldId id="261" r:id="rId6"/>
-    <p:sldId id="270" r:id="rId7"/>
-    <p:sldId id="265" r:id="rId8"/>
-    <p:sldId id="267" r:id="rId9"/>
-    <p:sldId id="269" r:id="rId10"/>
-    <p:sldId id="268" r:id="rId11"/>
-    <p:sldId id="272" r:id="rId12"/>
-    <p:sldId id="273" r:id="rId13"/>
-    <p:sldId id="274" r:id="rId14"/>
-    <p:sldId id="277" r:id="rId15"/>
-    <p:sldId id="275" r:id="rId16"/>
-    <p:sldId id="276" r:id="rId17"/>
-    <p:sldId id="263" r:id="rId18"/>
-    <p:sldId id="266" r:id="rId19"/>
+    <p:sldId id="278" r:id="rId4"/>
+    <p:sldId id="279" r:id="rId5"/>
+    <p:sldId id="258" r:id="rId6"/>
+    <p:sldId id="260" r:id="rId7"/>
+    <p:sldId id="261" r:id="rId8"/>
+    <p:sldId id="280" r:id="rId9"/>
+    <p:sldId id="265" r:id="rId10"/>
+    <p:sldId id="267" r:id="rId11"/>
+    <p:sldId id="269" r:id="rId12"/>
+    <p:sldId id="268" r:id="rId13"/>
+    <p:sldId id="281" r:id="rId14"/>
+    <p:sldId id="272" r:id="rId15"/>
+    <p:sldId id="273" r:id="rId16"/>
+    <p:sldId id="274" r:id="rId17"/>
+    <p:sldId id="277" r:id="rId18"/>
+    <p:sldId id="275" r:id="rId19"/>
+    <p:sldId id="276" r:id="rId20"/>
+    <p:sldId id="263" r:id="rId21"/>
+    <p:sldId id="266" r:id="rId22"/>
   </p:sldIdLst>
   <p:sldSz cx="12192000" cy="6858000"/>
   <p:notesSz cx="6858000" cy="9144000"/>
@@ -214,7 +217,7 @@
           <a:p>
             <a:fld id="{C82C5D2D-73FB-4054-908B-AB930B407DF2}" type="datetimeFigureOut">
               <a:rPr lang="en-US" smtClean="0"/>
-              <a:t>9/24/2025</a:t>
+              <a:t>8/6/2026</a:t>
             </a:fld>
             <a:endParaRPr lang="en-US"/>
           </a:p>
@@ -570,7 +573,7 @@
           <a:p>
             <a:fld id="{089AB531-42DD-4E57-818C-9DC7517959CC}" type="slidenum">
               <a:rPr lang="en-US" smtClean="0"/>
-              <a:t>7</a:t>
+              <a:t>9</a:t>
             </a:fld>
             <a:endParaRPr lang="en-US"/>
           </a:p>
@@ -678,7 +681,7 @@
           <a:p>
             <a:fld id="{089AB531-42DD-4E57-818C-9DC7517959CC}" type="slidenum">
               <a:rPr lang="en-US" smtClean="0"/>
-              <a:t>9</a:t>
+              <a:t>11</a:t>
             </a:fld>
             <a:endParaRPr lang="en-US"/>
           </a:p>
@@ -786,7 +789,7 @@
           <a:p>
             <a:fld id="{089AB531-42DD-4E57-818C-9DC7517959CC}" type="slidenum">
               <a:rPr lang="en-US" smtClean="0"/>
-              <a:t>11</a:t>
+              <a:t>14</a:t>
             </a:fld>
             <a:endParaRPr lang="en-US"/>
           </a:p>
@@ -894,7 +897,7 @@
           <a:p>
             <a:fld id="{089AB531-42DD-4E57-818C-9DC7517959CC}" type="slidenum">
               <a:rPr lang="en-US" smtClean="0"/>
-              <a:t>12</a:t>
+              <a:t>15</a:t>
             </a:fld>
             <a:endParaRPr lang="en-US"/>
           </a:p>
@@ -1002,7 +1005,7 @@
           <a:p>
             <a:fld id="{089AB531-42DD-4E57-818C-9DC7517959CC}" type="slidenum">
               <a:rPr lang="en-US" smtClean="0"/>
-              <a:t>13</a:t>
+              <a:t>16</a:t>
             </a:fld>
             <a:endParaRPr lang="en-US"/>
           </a:p>
@@ -1110,7 +1113,7 @@
           <a:p>
             <a:fld id="{089AB531-42DD-4E57-818C-9DC7517959CC}" type="slidenum">
               <a:rPr lang="en-US" smtClean="0"/>
-              <a:t>14</a:t>
+              <a:t>17</a:t>
             </a:fld>
             <a:endParaRPr lang="en-US"/>
           </a:p>
@@ -1218,7 +1221,7 @@
           <a:p>
             <a:fld id="{089AB531-42DD-4E57-818C-9DC7517959CC}" type="slidenum">
               <a:rPr lang="en-US" smtClean="0"/>
-              <a:t>15</a:t>
+              <a:t>18</a:t>
             </a:fld>
             <a:endParaRPr lang="en-US"/>
           </a:p>
@@ -1326,7 +1329,7 @@
           <a:p>
             <a:fld id="{089AB531-42DD-4E57-818C-9DC7517959CC}" type="slidenum">
               <a:rPr lang="en-US" smtClean="0"/>
-              <a:t>16</a:t>
+              <a:t>19</a:t>
             </a:fld>
             <a:endParaRPr lang="en-US"/>
           </a:p>
@@ -1410,7 +1413,7 @@
           <a:p>
             <a:fld id="{089AB531-42DD-4E57-818C-9DC7517959CC}" type="slidenum">
               <a:rPr lang="en-US" smtClean="0"/>
-              <a:t>17</a:t>
+              <a:t>20</a:t>
             </a:fld>
             <a:endParaRPr lang="en-US"/>
           </a:p>
@@ -1576,7 +1579,7 @@
           <a:p>
             <a:fld id="{AE1D7616-F1EA-4F87-8840-568991E174C4}" type="datetimeFigureOut">
               <a:rPr lang="en-US" smtClean="0"/>
-              <a:t>9/24/2025</a:t>
+              <a:t>8/6/2026</a:t>
             </a:fld>
             <a:endParaRPr lang="en-US"/>
           </a:p>
@@ -1774,7 +1777,7 @@
           <a:p>
             <a:fld id="{AE1D7616-F1EA-4F87-8840-568991E174C4}" type="datetimeFigureOut">
               <a:rPr lang="en-US" smtClean="0"/>
-              <a:t>9/24/2025</a:t>
+              <a:t>8/6/2026</a:t>
             </a:fld>
             <a:endParaRPr lang="en-US"/>
           </a:p>
@@ -1982,7 +1985,7 @@
           <a:p>
             <a:fld id="{AE1D7616-F1EA-4F87-8840-568991E174C4}" type="datetimeFigureOut">
               <a:rPr lang="en-US" smtClean="0"/>
-              <a:t>9/24/2025</a:t>
+              <a:t>8/6/2026</a:t>
             </a:fld>
             <a:endParaRPr lang="en-US"/>
           </a:p>
@@ -2180,7 +2183,7 @@
           <a:p>
             <a:fld id="{AE1D7616-F1EA-4F87-8840-568991E174C4}" type="datetimeFigureOut">
               <a:rPr lang="en-US" smtClean="0"/>
-              <a:t>9/24/2025</a:t>
+              <a:t>8/6/2026</a:t>
             </a:fld>
             <a:endParaRPr lang="en-US"/>
           </a:p>
@@ -2455,7 +2458,7 @@
           <a:p>
             <a:fld id="{AE1D7616-F1EA-4F87-8840-568991E174C4}" type="datetimeFigureOut">
               <a:rPr lang="en-US" smtClean="0"/>
-              <a:t>9/24/2025</a:t>
+              <a:t>8/6/2026</a:t>
             </a:fld>
             <a:endParaRPr lang="en-US"/>
           </a:p>
@@ -2720,7 +2723,7 @@
           <a:p>
             <a:fld id="{AE1D7616-F1EA-4F87-8840-568991E174C4}" type="datetimeFigureOut">
               <a:rPr lang="en-US" smtClean="0"/>
-              <a:t>9/24/2025</a:t>
+              <a:t>8/6/2026</a:t>
             </a:fld>
             <a:endParaRPr lang="en-US"/>
           </a:p>
@@ -3132,7 +3135,7 @@
           <a:p>
             <a:fld id="{AE1D7616-F1EA-4F87-8840-568991E174C4}" type="datetimeFigureOut">
               <a:rPr lang="en-US" smtClean="0"/>
-              <a:t>9/24/2025</a:t>
+              <a:t>8/6/2026</a:t>
             </a:fld>
             <a:endParaRPr lang="en-US"/>
           </a:p>
@@ -3273,7 +3276,7 @@
           <a:p>
             <a:fld id="{AE1D7616-F1EA-4F87-8840-568991E174C4}" type="datetimeFigureOut">
               <a:rPr lang="en-US" smtClean="0"/>
-              <a:t>9/24/2025</a:t>
+              <a:t>8/6/2026</a:t>
             </a:fld>
             <a:endParaRPr lang="en-US"/>
           </a:p>
@@ -3386,7 +3389,7 @@
           <a:p>
             <a:fld id="{AE1D7616-F1EA-4F87-8840-568991E174C4}" type="datetimeFigureOut">
               <a:rPr lang="en-US" smtClean="0"/>
-              <a:t>9/24/2025</a:t>
+              <a:t>8/6/2026</a:t>
             </a:fld>
             <a:endParaRPr lang="en-US"/>
           </a:p>
@@ -3697,7 +3700,7 @@
           <a:p>
             <a:fld id="{AE1D7616-F1EA-4F87-8840-568991E174C4}" type="datetimeFigureOut">
               <a:rPr lang="en-US" smtClean="0"/>
-              <a:t>9/24/2025</a:t>
+              <a:t>8/6/2026</a:t>
             </a:fld>
             <a:endParaRPr lang="en-US"/>
           </a:p>
@@ -3985,7 +3988,7 @@
           <a:p>
             <a:fld id="{AE1D7616-F1EA-4F87-8840-568991E174C4}" type="datetimeFigureOut">
               <a:rPr lang="en-US" smtClean="0"/>
-              <a:t>9/24/2025</a:t>
+              <a:t>8/6/2026</a:t>
             </a:fld>
             <a:endParaRPr lang="en-US"/>
           </a:p>
@@ -4226,7 +4229,7 @@
           <a:p>
             <a:fld id="{AE1D7616-F1EA-4F87-8840-568991E174C4}" type="datetimeFigureOut">
               <a:rPr lang="en-US" smtClean="0"/>
-              <a:t>9/24/2025</a:t>
+              <a:t>8/6/2026</a:t>
             </a:fld>
             <a:endParaRPr lang="en-US"/>
           </a:p>
@@ -4319,6 +4322,54 @@
               <a:t>‹#›</a:t>
             </a:fld>
             <a:endParaRPr lang="en-US"/>
+          </a:p>
+        </p:txBody>
+      </p:sp>
+      <p:sp>
+        <p:nvSpPr>
+          <p:cNvPr id="8" name="TextBox 7">
+            <a:extLst>
+              <a:ext uri="{FF2B5EF4-FFF2-40B4-BE49-F238E27FC236}">
+                <a16:creationId xmlns:a16="http://schemas.microsoft.com/office/drawing/2014/main" id="{8086CC9A-BC1F-25EC-9ED4-978F4128C9F4}"/>
+              </a:ext>
+            </a:extLst>
+          </p:cNvPr>
+          <p:cNvSpPr txBox="1"/>
+          <p:nvPr userDrawn="1">
+            <p:extLst>
+              <p:ext uri="{1162E1C5-73C7-4A58-AE30-91384D911F3F}">
+                <p184:classification xmlns:p184="http://schemas.microsoft.com/office/powerpoint/2018/4/main" val="ftr"/>
+              </p:ext>
+            </p:extLst>
+          </p:nvPr>
+        </p:nvSpPr>
+        <p:spPr>
+          <a:xfrm>
+            <a:off x="63500" y="6642100"/>
+            <a:ext cx="1220788" cy="152400"/>
+          </a:xfrm>
+          <a:prstGeom prst="rect">
+            <a:avLst/>
+          </a:prstGeom>
+        </p:spPr>
+        <p:txBody>
+          <a:bodyPr horzOverflow="overflow" lIns="0" tIns="0" rIns="0" bIns="0">
+            <a:spAutoFit/>
+          </a:bodyPr>
+          <a:lstStyle/>
+          <a:p>
+            <a:pPr algn="l"/>
+            <a:r>
+              <a:rPr lang="en-US" sz="1000">
+                <a:solidFill>
+                  <a:srgbClr val="000000">
+                    <a:alpha val="50000"/>
+                  </a:srgbClr>
+                </a:solidFill>
+                <a:latin typeface="Aptos" panose="020B0004020202020204" pitchFamily="34" charset="0"/>
+              </a:rPr>
+              <a:t>St. Jude - Confidential</a:t>
+            </a:r>
           </a:p>
         </p:txBody>
       </p:sp>
@@ -4700,7 +4751,7 @@
           <a:p>
             <a:r>
               <a:rPr lang="en-US" dirty="0"/>
-              <a:t>Last update 9/24/2025</a:t>
+              <a:t>Last update 8/6/2026</a:t>
             </a:r>
           </a:p>
         </p:txBody>
@@ -4719,6 +4770,436 @@
 </file>
 
 <file path=ppt/slides/slide10.xml><?xml version="1.0" encoding="utf-8"?>
+<p:sld xmlns:a="http://schemas.openxmlformats.org/drawingml/2006/main" xmlns:r="http://schemas.openxmlformats.org/officeDocument/2006/relationships" xmlns:p="http://schemas.openxmlformats.org/presentationml/2006/main">
+  <p:cSld>
+    <p:spTree>
+      <p:nvGrpSpPr>
+        <p:cNvPr id="1" name=""/>
+        <p:cNvGrpSpPr/>
+        <p:nvPr/>
+      </p:nvGrpSpPr>
+      <p:grpSpPr>
+        <a:xfrm>
+          <a:off x="0" y="0"/>
+          <a:ext cx="0" cy="0"/>
+          <a:chOff x="0" y="0"/>
+          <a:chExt cx="0" cy="0"/>
+        </a:xfrm>
+      </p:grpSpPr>
+      <p:sp>
+        <p:nvSpPr>
+          <p:cNvPr id="2" name="Title 1">
+            <a:extLst>
+              <a:ext uri="{FF2B5EF4-FFF2-40B4-BE49-F238E27FC236}">
+                <a16:creationId xmlns:a16="http://schemas.microsoft.com/office/drawing/2014/main" id="{2E026C02-9456-53C2-4AAD-3B57C20C3C65}"/>
+              </a:ext>
+            </a:extLst>
+          </p:cNvPr>
+          <p:cNvSpPr>
+            <a:spLocks noGrp="1"/>
+          </p:cNvSpPr>
+          <p:nvPr>
+            <p:ph type="title"/>
+          </p:nvPr>
+        </p:nvSpPr>
+        <p:spPr/>
+        <p:txBody>
+          <a:bodyPr/>
+          <a:lstStyle/>
+          <a:p>
+            <a:r>
+              <a:rPr lang="en-US" dirty="0"/>
+              <a:t>Connecting to DataWrangling2025 SQL Server through SAS Server (cont.)</a:t>
+            </a:r>
+          </a:p>
+        </p:txBody>
+      </p:sp>
+      <p:sp>
+        <p:nvSpPr>
+          <p:cNvPr id="3" name="Content Placeholder 2">
+            <a:extLst>
+              <a:ext uri="{FF2B5EF4-FFF2-40B4-BE49-F238E27FC236}">
+                <a16:creationId xmlns:a16="http://schemas.microsoft.com/office/drawing/2014/main" id="{07450B49-6BF5-5612-32D5-91EC0AB85680}"/>
+              </a:ext>
+            </a:extLst>
+          </p:cNvPr>
+          <p:cNvSpPr>
+            <a:spLocks noGrp="1"/>
+          </p:cNvSpPr>
+          <p:nvPr>
+            <p:ph idx="1"/>
+          </p:nvPr>
+        </p:nvSpPr>
+        <p:spPr/>
+        <p:txBody>
+          <a:bodyPr/>
+          <a:lstStyle/>
+          <a:p>
+            <a:r>
+              <a:rPr lang="en-US" dirty="0"/>
+              <a:t>Expected output from method 1 - DSN</a:t>
+            </a:r>
+          </a:p>
+          <a:p>
+            <a:endParaRPr lang="en-US" dirty="0"/>
+          </a:p>
+          <a:p>
+            <a:endParaRPr lang="en-US" dirty="0"/>
+          </a:p>
+        </p:txBody>
+      </p:sp>
+      <p:pic>
+        <p:nvPicPr>
+          <p:cNvPr id="5" name="Picture 4">
+            <a:extLst>
+              <a:ext uri="{FF2B5EF4-FFF2-40B4-BE49-F238E27FC236}">
+                <a16:creationId xmlns:a16="http://schemas.microsoft.com/office/drawing/2014/main" id="{2B12CF7A-1E0F-4B49-7473-4910704DA75C}"/>
+              </a:ext>
+            </a:extLst>
+          </p:cNvPr>
+          <p:cNvPicPr>
+            <a:picLocks noChangeAspect="1"/>
+          </p:cNvPicPr>
+          <p:nvPr/>
+        </p:nvPicPr>
+        <p:blipFill>
+          <a:blip r:embed="rId2"/>
+          <a:stretch>
+            <a:fillRect/>
+          </a:stretch>
+        </p:blipFill>
+        <p:spPr>
+          <a:xfrm>
+            <a:off x="641605" y="2683594"/>
+            <a:ext cx="5095580" cy="3445095"/>
+          </a:xfrm>
+          <a:prstGeom prst="rect">
+            <a:avLst/>
+          </a:prstGeom>
+        </p:spPr>
+      </p:pic>
+      <p:pic>
+        <p:nvPicPr>
+          <p:cNvPr id="8" name="Picture 7">
+            <a:extLst>
+              <a:ext uri="{FF2B5EF4-FFF2-40B4-BE49-F238E27FC236}">
+                <a16:creationId xmlns:a16="http://schemas.microsoft.com/office/drawing/2014/main" id="{32F490B2-5805-E843-A846-B6F2B89465EE}"/>
+              </a:ext>
+            </a:extLst>
+          </p:cNvPr>
+          <p:cNvPicPr>
+            <a:picLocks noChangeAspect="1"/>
+          </p:cNvPicPr>
+          <p:nvPr/>
+        </p:nvPicPr>
+        <p:blipFill>
+          <a:blip r:embed="rId3"/>
+          <a:stretch>
+            <a:fillRect/>
+          </a:stretch>
+        </p:blipFill>
+        <p:spPr>
+          <a:xfrm>
+            <a:off x="6251641" y="2683595"/>
+            <a:ext cx="5616615" cy="3429000"/>
+          </a:xfrm>
+          <a:prstGeom prst="rect">
+            <a:avLst/>
+          </a:prstGeom>
+        </p:spPr>
+      </p:pic>
+      <p:sp>
+        <p:nvSpPr>
+          <p:cNvPr id="9" name="Rectangle: Rounded Corners 8">
+            <a:hlinkClick r:id="rId4" action="ppaction://hlinksldjump"/>
+            <a:extLst>
+              <a:ext uri="{FF2B5EF4-FFF2-40B4-BE49-F238E27FC236}">
+                <a16:creationId xmlns:a16="http://schemas.microsoft.com/office/drawing/2014/main" id="{ED66CBD8-C249-4B93-9442-984FD8E8594D}"/>
+              </a:ext>
+            </a:extLst>
+          </p:cNvPr>
+          <p:cNvSpPr/>
+          <p:nvPr/>
+        </p:nvSpPr>
+        <p:spPr>
+          <a:xfrm>
+            <a:off x="11226800" y="107950"/>
+            <a:ext cx="812800" cy="317500"/>
+          </a:xfrm>
+          <a:prstGeom prst="roundRect">
+            <a:avLst/>
+          </a:prstGeom>
+        </p:spPr>
+        <p:style>
+          <a:lnRef idx="1">
+            <a:schemeClr val="accent4"/>
+          </a:lnRef>
+          <a:fillRef idx="2">
+            <a:schemeClr val="accent4"/>
+          </a:fillRef>
+          <a:effectRef idx="1">
+            <a:schemeClr val="accent4"/>
+          </a:effectRef>
+          <a:fontRef idx="minor">
+            <a:schemeClr val="dk1"/>
+          </a:fontRef>
+        </p:style>
+        <p:txBody>
+          <a:bodyPr rtlCol="0" anchor="ctr"/>
+          <a:lstStyle/>
+          <a:p>
+            <a:pPr algn="ctr"/>
+            <a:r>
+              <a:rPr lang="en-US" sz="1200" dirty="0"/>
+              <a:t>HOME</a:t>
+            </a:r>
+          </a:p>
+        </p:txBody>
+      </p:sp>
+    </p:spTree>
+    <p:extLst>
+      <p:ext uri="{BB962C8B-B14F-4D97-AF65-F5344CB8AC3E}">
+        <p14:creationId xmlns:p14="http://schemas.microsoft.com/office/powerpoint/2010/main" val="2252906759"/>
+      </p:ext>
+    </p:extLst>
+  </p:cSld>
+  <p:clrMapOvr>
+    <a:masterClrMapping/>
+  </p:clrMapOvr>
+</p:sld>
+</file>
+
+<file path=ppt/slides/slide11.xml><?xml version="1.0" encoding="utf-8"?>
+<p:sld xmlns:a="http://schemas.openxmlformats.org/drawingml/2006/main" xmlns:r="http://schemas.openxmlformats.org/officeDocument/2006/relationships" xmlns:p="http://schemas.openxmlformats.org/presentationml/2006/main">
+  <p:cSld>
+    <p:spTree>
+      <p:nvGrpSpPr>
+        <p:cNvPr id="1" name="">
+          <a:extLst>
+            <a:ext uri="{FF2B5EF4-FFF2-40B4-BE49-F238E27FC236}">
+              <a16:creationId xmlns:a16="http://schemas.microsoft.com/office/drawing/2014/main" id="{099E537E-A796-B785-204B-6FC35C35BD71}"/>
+            </a:ext>
+          </a:extLst>
+        </p:cNvPr>
+        <p:cNvGrpSpPr/>
+        <p:nvPr/>
+      </p:nvGrpSpPr>
+      <p:grpSpPr>
+        <a:xfrm>
+          <a:off x="0" y="0"/>
+          <a:ext cx="0" cy="0"/>
+          <a:chOff x="0" y="0"/>
+          <a:chExt cx="0" cy="0"/>
+        </a:xfrm>
+      </p:grpSpPr>
+      <p:sp>
+        <p:nvSpPr>
+          <p:cNvPr id="2" name="Title 1">
+            <a:extLst>
+              <a:ext uri="{FF2B5EF4-FFF2-40B4-BE49-F238E27FC236}">
+                <a16:creationId xmlns:a16="http://schemas.microsoft.com/office/drawing/2014/main" id="{AFA8BCB4-E432-3E7C-B0B9-D2BA4B055077}"/>
+              </a:ext>
+            </a:extLst>
+          </p:cNvPr>
+          <p:cNvSpPr>
+            <a:spLocks noGrp="1"/>
+          </p:cNvSpPr>
+          <p:nvPr>
+            <p:ph type="title"/>
+          </p:nvPr>
+        </p:nvSpPr>
+        <p:spPr/>
+        <p:txBody>
+          <a:bodyPr/>
+          <a:lstStyle/>
+          <a:p>
+            <a:r>
+              <a:rPr lang="en-US" dirty="0"/>
+              <a:t>Connecting to DataWrangling2025 SQL Server through SAS Server (cont.)</a:t>
+            </a:r>
+          </a:p>
+        </p:txBody>
+      </p:sp>
+      <p:sp>
+        <p:nvSpPr>
+          <p:cNvPr id="3" name="Content Placeholder 2">
+            <a:extLst>
+              <a:ext uri="{FF2B5EF4-FFF2-40B4-BE49-F238E27FC236}">
+                <a16:creationId xmlns:a16="http://schemas.microsoft.com/office/drawing/2014/main" id="{7F3AE4DB-035A-3749-77C9-561C2A4B5D1A}"/>
+              </a:ext>
+            </a:extLst>
+          </p:cNvPr>
+          <p:cNvSpPr>
+            <a:spLocks noGrp="1"/>
+          </p:cNvSpPr>
+          <p:nvPr>
+            <p:ph idx="1"/>
+          </p:nvPr>
+        </p:nvSpPr>
+        <p:spPr>
+          <a:xfrm>
+            <a:off x="838200" y="1825625"/>
+            <a:ext cx="5458838" cy="4351338"/>
+          </a:xfrm>
+        </p:spPr>
+        <p:txBody>
+          <a:bodyPr>
+            <a:normAutofit/>
+          </a:bodyPr>
+          <a:lstStyle/>
+          <a:p>
+            <a:pPr marL="0" indent="0">
+              <a:buNone/>
+            </a:pPr>
+            <a:r>
+              <a:rPr lang="en-US" b="1" dirty="0"/>
+              <a:t>Using proc </a:t>
+            </a:r>
+            <a:r>
+              <a:rPr lang="en-US" b="1" dirty="0" err="1"/>
+              <a:t>sql</a:t>
+            </a:r>
+            <a:endParaRPr lang="en-US" b="1" dirty="0"/>
+          </a:p>
+          <a:p>
+            <a:r>
+              <a:rPr lang="en-US" dirty="0"/>
+              <a:t>Run </a:t>
+            </a:r>
+            <a:r>
+              <a:rPr lang="en-US" dirty="0" err="1"/>
+              <a:t>test_sql.sas</a:t>
+            </a:r>
+            <a:r>
+              <a:rPr lang="en-US" dirty="0"/>
+              <a:t> (lines 19-28) in SAS Studio</a:t>
+            </a:r>
+          </a:p>
+          <a:p>
+            <a:r>
+              <a:rPr lang="en-US" dirty="0"/>
+              <a:t>See next slide for the expected output</a:t>
+            </a:r>
+          </a:p>
+          <a:p>
+            <a:r>
+              <a:rPr lang="en-US" dirty="0"/>
+              <a:t>If you do not see the expected outputs, email </a:t>
+            </a:r>
+            <a:r>
+              <a:rPr lang="en-US" dirty="0">
+                <a:hlinkClick r:id="rId3"/>
+              </a:rPr>
+              <a:t>Yichen.chen@stjude.org</a:t>
+            </a:r>
+            <a:r>
+              <a:rPr lang="en-US" dirty="0"/>
+              <a:t> with screenshot</a:t>
+            </a:r>
+          </a:p>
+          <a:p>
+            <a:endParaRPr lang="en-US" dirty="0"/>
+          </a:p>
+          <a:p>
+            <a:pPr marL="0" indent="0">
+              <a:buNone/>
+            </a:pPr>
+            <a:endParaRPr lang="en-US" dirty="0"/>
+          </a:p>
+        </p:txBody>
+      </p:sp>
+      <p:pic>
+        <p:nvPicPr>
+          <p:cNvPr id="6" name="Picture 5">
+            <a:extLst>
+              <a:ext uri="{FF2B5EF4-FFF2-40B4-BE49-F238E27FC236}">
+                <a16:creationId xmlns:a16="http://schemas.microsoft.com/office/drawing/2014/main" id="{232D671F-1BF7-2FE2-96EC-9F3BBBE70B10}"/>
+              </a:ext>
+            </a:extLst>
+          </p:cNvPr>
+          <p:cNvPicPr>
+            <a:picLocks noChangeAspect="1"/>
+          </p:cNvPicPr>
+          <p:nvPr/>
+        </p:nvPicPr>
+        <p:blipFill>
+          <a:blip r:embed="rId4"/>
+          <a:stretch>
+            <a:fillRect/>
+          </a:stretch>
+        </p:blipFill>
+        <p:spPr>
+          <a:xfrm>
+            <a:off x="6096000" y="2875619"/>
+            <a:ext cx="6004858" cy="2150339"/>
+          </a:xfrm>
+          <a:prstGeom prst="rect">
+            <a:avLst/>
+          </a:prstGeom>
+        </p:spPr>
+      </p:pic>
+      <p:sp>
+        <p:nvSpPr>
+          <p:cNvPr id="5" name="Rectangle: Rounded Corners 4">
+            <a:hlinkClick r:id="rId5" action="ppaction://hlinksldjump"/>
+            <a:extLst>
+              <a:ext uri="{FF2B5EF4-FFF2-40B4-BE49-F238E27FC236}">
+                <a16:creationId xmlns:a16="http://schemas.microsoft.com/office/drawing/2014/main" id="{82CA82C4-30A4-9B51-4696-C828621424F3}"/>
+              </a:ext>
+            </a:extLst>
+          </p:cNvPr>
+          <p:cNvSpPr/>
+          <p:nvPr/>
+        </p:nvSpPr>
+        <p:spPr>
+          <a:xfrm>
+            <a:off x="11226800" y="107950"/>
+            <a:ext cx="812800" cy="317500"/>
+          </a:xfrm>
+          <a:prstGeom prst="roundRect">
+            <a:avLst/>
+          </a:prstGeom>
+        </p:spPr>
+        <p:style>
+          <a:lnRef idx="1">
+            <a:schemeClr val="accent4"/>
+          </a:lnRef>
+          <a:fillRef idx="2">
+            <a:schemeClr val="accent4"/>
+          </a:fillRef>
+          <a:effectRef idx="1">
+            <a:schemeClr val="accent4"/>
+          </a:effectRef>
+          <a:fontRef idx="minor">
+            <a:schemeClr val="dk1"/>
+          </a:fontRef>
+        </p:style>
+        <p:txBody>
+          <a:bodyPr rtlCol="0" anchor="ctr"/>
+          <a:lstStyle/>
+          <a:p>
+            <a:pPr algn="ctr"/>
+            <a:r>
+              <a:rPr lang="en-US" sz="1200" dirty="0"/>
+              <a:t>HOME</a:t>
+            </a:r>
+          </a:p>
+        </p:txBody>
+      </p:sp>
+    </p:spTree>
+    <p:extLst>
+      <p:ext uri="{BB962C8B-B14F-4D97-AF65-F5344CB8AC3E}">
+        <p14:creationId xmlns:p14="http://schemas.microsoft.com/office/powerpoint/2010/main" val="1092146382"/>
+      </p:ext>
+    </p:extLst>
+  </p:cSld>
+  <p:clrMapOvr>
+    <a:masterClrMapping/>
+  </p:clrMapOvr>
+</p:sld>
+</file>
+
+<file path=ppt/slides/slide12.xml><?xml version="1.0" encoding="utf-8"?>
 <p:sld xmlns:a="http://schemas.openxmlformats.org/drawingml/2006/main" xmlns:r="http://schemas.openxmlformats.org/officeDocument/2006/relationships" xmlns:p="http://schemas.openxmlformats.org/presentationml/2006/main">
   <p:cSld>
     <p:spTree>
@@ -4838,6 +5319,54 @@
           </a:prstGeom>
         </p:spPr>
       </p:pic>
+      <p:sp>
+        <p:nvSpPr>
+          <p:cNvPr id="5" name="Rectangle: Rounded Corners 4">
+            <a:hlinkClick r:id="rId3" action="ppaction://hlinksldjump"/>
+            <a:extLst>
+              <a:ext uri="{FF2B5EF4-FFF2-40B4-BE49-F238E27FC236}">
+                <a16:creationId xmlns:a16="http://schemas.microsoft.com/office/drawing/2014/main" id="{B646DE70-6905-8EC1-6FD1-52B051012A25}"/>
+              </a:ext>
+            </a:extLst>
+          </p:cNvPr>
+          <p:cNvSpPr/>
+          <p:nvPr/>
+        </p:nvSpPr>
+        <p:spPr>
+          <a:xfrm>
+            <a:off x="11226800" y="107950"/>
+            <a:ext cx="812800" cy="317500"/>
+          </a:xfrm>
+          <a:prstGeom prst="roundRect">
+            <a:avLst/>
+          </a:prstGeom>
+        </p:spPr>
+        <p:style>
+          <a:lnRef idx="1">
+            <a:schemeClr val="accent4"/>
+          </a:lnRef>
+          <a:fillRef idx="2">
+            <a:schemeClr val="accent4"/>
+          </a:fillRef>
+          <a:effectRef idx="1">
+            <a:schemeClr val="accent4"/>
+          </a:effectRef>
+          <a:fontRef idx="minor">
+            <a:schemeClr val="dk1"/>
+          </a:fontRef>
+        </p:style>
+        <p:txBody>
+          <a:bodyPr rtlCol="0" anchor="ctr"/>
+          <a:lstStyle/>
+          <a:p>
+            <a:pPr algn="ctr"/>
+            <a:r>
+              <a:rPr lang="en-US" sz="1200" dirty="0"/>
+              <a:t>HOME</a:t>
+            </a:r>
+          </a:p>
+        </p:txBody>
+      </p:sp>
     </p:spTree>
     <p:extLst>
       <p:ext uri="{BB962C8B-B14F-4D97-AF65-F5344CB8AC3E}">
@@ -4851,7 +5380,138 @@
 </p:sld>
 </file>
 
-<file path=ppt/slides/slide11.xml><?xml version="1.0" encoding="utf-8"?>
+<file path=ppt/slides/slide13.xml><?xml version="1.0" encoding="utf-8"?>
+<p:sld xmlns:a="http://schemas.openxmlformats.org/drawingml/2006/main" xmlns:r="http://schemas.openxmlformats.org/officeDocument/2006/relationships" xmlns:p="http://schemas.openxmlformats.org/presentationml/2006/main">
+  <p:cSld>
+    <p:spTree>
+      <p:nvGrpSpPr>
+        <p:cNvPr id="1" name=""/>
+        <p:cNvGrpSpPr/>
+        <p:nvPr/>
+      </p:nvGrpSpPr>
+      <p:grpSpPr>
+        <a:xfrm>
+          <a:off x="0" y="0"/>
+          <a:ext cx="0" cy="0"/>
+          <a:chOff x="0" y="0"/>
+          <a:chExt cx="0" cy="0"/>
+        </a:xfrm>
+      </p:grpSpPr>
+      <p:sp>
+        <p:nvSpPr>
+          <p:cNvPr id="2" name="Title 1">
+            <a:extLst>
+              <a:ext uri="{FF2B5EF4-FFF2-40B4-BE49-F238E27FC236}">
+                <a16:creationId xmlns:a16="http://schemas.microsoft.com/office/drawing/2014/main" id="{581201DD-6359-D091-113C-BD30BCE61EA6}"/>
+              </a:ext>
+            </a:extLst>
+          </p:cNvPr>
+          <p:cNvSpPr>
+            <a:spLocks noGrp="1"/>
+          </p:cNvSpPr>
+          <p:nvPr>
+            <p:ph type="title"/>
+          </p:nvPr>
+        </p:nvSpPr>
+        <p:spPr/>
+        <p:txBody>
+          <a:bodyPr/>
+          <a:lstStyle/>
+          <a:p>
+            <a:r>
+              <a:rPr lang="en-US" dirty="0"/>
+              <a:t>R</a:t>
+            </a:r>
+          </a:p>
+        </p:txBody>
+      </p:sp>
+      <p:sp>
+        <p:nvSpPr>
+          <p:cNvPr id="3" name="Text Placeholder 2">
+            <a:extLst>
+              <a:ext uri="{FF2B5EF4-FFF2-40B4-BE49-F238E27FC236}">
+                <a16:creationId xmlns:a16="http://schemas.microsoft.com/office/drawing/2014/main" id="{9E587A47-E6DF-8618-907D-F969A7BB155F}"/>
+              </a:ext>
+            </a:extLst>
+          </p:cNvPr>
+          <p:cNvSpPr>
+            <a:spLocks noGrp="1"/>
+          </p:cNvSpPr>
+          <p:nvPr>
+            <p:ph type="body" idx="1"/>
+          </p:nvPr>
+        </p:nvSpPr>
+        <p:spPr/>
+        <p:txBody>
+          <a:bodyPr/>
+          <a:lstStyle/>
+          <a:p>
+            <a:endParaRPr lang="en-US"/>
+          </a:p>
+        </p:txBody>
+      </p:sp>
+      <p:sp>
+        <p:nvSpPr>
+          <p:cNvPr id="5" name="Rectangle: Rounded Corners 4">
+            <a:hlinkClick r:id="rId2" action="ppaction://hlinksldjump"/>
+            <a:extLst>
+              <a:ext uri="{FF2B5EF4-FFF2-40B4-BE49-F238E27FC236}">
+                <a16:creationId xmlns:a16="http://schemas.microsoft.com/office/drawing/2014/main" id="{9D17A6D4-8CF0-5379-17AD-BB59F2FE0409}"/>
+              </a:ext>
+            </a:extLst>
+          </p:cNvPr>
+          <p:cNvSpPr/>
+          <p:nvPr/>
+        </p:nvSpPr>
+        <p:spPr>
+          <a:xfrm>
+            <a:off x="11226800" y="107950"/>
+            <a:ext cx="812800" cy="317500"/>
+          </a:xfrm>
+          <a:prstGeom prst="roundRect">
+            <a:avLst/>
+          </a:prstGeom>
+        </p:spPr>
+        <p:style>
+          <a:lnRef idx="1">
+            <a:schemeClr val="accent4"/>
+          </a:lnRef>
+          <a:fillRef idx="2">
+            <a:schemeClr val="accent4"/>
+          </a:fillRef>
+          <a:effectRef idx="1">
+            <a:schemeClr val="accent4"/>
+          </a:effectRef>
+          <a:fontRef idx="minor">
+            <a:schemeClr val="dk1"/>
+          </a:fontRef>
+        </p:style>
+        <p:txBody>
+          <a:bodyPr rtlCol="0" anchor="ctr"/>
+          <a:lstStyle/>
+          <a:p>
+            <a:pPr algn="ctr"/>
+            <a:r>
+              <a:rPr lang="en-US" sz="1200" dirty="0"/>
+              <a:t>HOME</a:t>
+            </a:r>
+          </a:p>
+        </p:txBody>
+      </p:sp>
+    </p:spTree>
+    <p:extLst>
+      <p:ext uri="{BB962C8B-B14F-4D97-AF65-F5344CB8AC3E}">
+        <p14:creationId xmlns:p14="http://schemas.microsoft.com/office/powerpoint/2010/main" val="3865631645"/>
+      </p:ext>
+    </p:extLst>
+  </p:cSld>
+  <p:clrMapOvr>
+    <a:masterClrMapping/>
+  </p:clrMapOvr>
+</p:sld>
+</file>
+
+<file path=ppt/slides/slide14.xml><?xml version="1.0" encoding="utf-8"?>
 <p:sld xmlns:a="http://schemas.openxmlformats.org/drawingml/2006/main" xmlns:r="http://schemas.openxmlformats.org/officeDocument/2006/relationships" xmlns:p="http://schemas.openxmlformats.org/presentationml/2006/main">
   <p:cSld>
     <p:spTree>
@@ -5020,6 +5680,54 @@
           </a:prstGeom>
         </p:spPr>
       </p:pic>
+      <p:sp>
+        <p:nvSpPr>
+          <p:cNvPr id="6" name="Rectangle: Rounded Corners 5">
+            <a:hlinkClick r:id="rId5" action="ppaction://hlinksldjump"/>
+            <a:extLst>
+              <a:ext uri="{FF2B5EF4-FFF2-40B4-BE49-F238E27FC236}">
+                <a16:creationId xmlns:a16="http://schemas.microsoft.com/office/drawing/2014/main" id="{8596F870-8509-AD25-3101-8908B0B86747}"/>
+              </a:ext>
+            </a:extLst>
+          </p:cNvPr>
+          <p:cNvSpPr/>
+          <p:nvPr/>
+        </p:nvSpPr>
+        <p:spPr>
+          <a:xfrm>
+            <a:off x="11226800" y="107950"/>
+            <a:ext cx="812800" cy="317500"/>
+          </a:xfrm>
+          <a:prstGeom prst="roundRect">
+            <a:avLst/>
+          </a:prstGeom>
+        </p:spPr>
+        <p:style>
+          <a:lnRef idx="1">
+            <a:schemeClr val="accent4"/>
+          </a:lnRef>
+          <a:fillRef idx="2">
+            <a:schemeClr val="accent4"/>
+          </a:fillRef>
+          <a:effectRef idx="1">
+            <a:schemeClr val="accent4"/>
+          </a:effectRef>
+          <a:fontRef idx="minor">
+            <a:schemeClr val="dk1"/>
+          </a:fontRef>
+        </p:style>
+        <p:txBody>
+          <a:bodyPr rtlCol="0" anchor="ctr"/>
+          <a:lstStyle/>
+          <a:p>
+            <a:pPr algn="ctr"/>
+            <a:r>
+              <a:rPr lang="en-US" sz="1200" dirty="0"/>
+              <a:t>HOME</a:t>
+            </a:r>
+          </a:p>
+        </p:txBody>
+      </p:sp>
     </p:spTree>
     <p:extLst>
       <p:ext uri="{BB962C8B-B14F-4D97-AF65-F5344CB8AC3E}">
@@ -5033,7 +5741,7 @@
 </p:sld>
 </file>
 
-<file path=ppt/slides/slide12.xml><?xml version="1.0" encoding="utf-8"?>
+<file path=ppt/slides/slide15.xml><?xml version="1.0" encoding="utf-8"?>
 <p:sld xmlns:a="http://schemas.openxmlformats.org/drawingml/2006/main" xmlns:r="http://schemas.openxmlformats.org/officeDocument/2006/relationships" xmlns:p="http://schemas.openxmlformats.org/presentationml/2006/main">
   <p:cSld>
     <p:spTree>
@@ -5213,6 +5921,54 @@
           </a:prstGeom>
         </p:spPr>
       </p:pic>
+      <p:sp>
+        <p:nvSpPr>
+          <p:cNvPr id="5" name="Rectangle: Rounded Corners 4">
+            <a:hlinkClick r:id="rId5" action="ppaction://hlinksldjump"/>
+            <a:extLst>
+              <a:ext uri="{FF2B5EF4-FFF2-40B4-BE49-F238E27FC236}">
+                <a16:creationId xmlns:a16="http://schemas.microsoft.com/office/drawing/2014/main" id="{8C11D7D2-0CA6-A458-6A36-D62900E08872}"/>
+              </a:ext>
+            </a:extLst>
+          </p:cNvPr>
+          <p:cNvSpPr/>
+          <p:nvPr/>
+        </p:nvSpPr>
+        <p:spPr>
+          <a:xfrm>
+            <a:off x="11226800" y="107950"/>
+            <a:ext cx="812800" cy="317500"/>
+          </a:xfrm>
+          <a:prstGeom prst="roundRect">
+            <a:avLst/>
+          </a:prstGeom>
+        </p:spPr>
+        <p:style>
+          <a:lnRef idx="1">
+            <a:schemeClr val="accent4"/>
+          </a:lnRef>
+          <a:fillRef idx="2">
+            <a:schemeClr val="accent4"/>
+          </a:fillRef>
+          <a:effectRef idx="1">
+            <a:schemeClr val="accent4"/>
+          </a:effectRef>
+          <a:fontRef idx="minor">
+            <a:schemeClr val="dk1"/>
+          </a:fontRef>
+        </p:style>
+        <p:txBody>
+          <a:bodyPr rtlCol="0" anchor="ctr"/>
+          <a:lstStyle/>
+          <a:p>
+            <a:pPr algn="ctr"/>
+            <a:r>
+              <a:rPr lang="en-US" sz="1200" dirty="0"/>
+              <a:t>HOME</a:t>
+            </a:r>
+          </a:p>
+        </p:txBody>
+      </p:sp>
     </p:spTree>
     <p:extLst>
       <p:ext uri="{BB962C8B-B14F-4D97-AF65-F5344CB8AC3E}">
@@ -5226,7 +5982,7 @@
 </p:sld>
 </file>
 
-<file path=ppt/slides/slide13.xml><?xml version="1.0" encoding="utf-8"?>
+<file path=ppt/slides/slide16.xml><?xml version="1.0" encoding="utf-8"?>
 <p:sld xmlns:a="http://schemas.openxmlformats.org/drawingml/2006/main" xmlns:r="http://schemas.openxmlformats.org/officeDocument/2006/relationships" xmlns:p="http://schemas.openxmlformats.org/presentationml/2006/main">
   <p:cSld>
     <p:spTree>
@@ -5459,6 +6215,54 @@
           </a:prstGeom>
         </p:spPr>
       </p:pic>
+      <p:sp>
+        <p:nvSpPr>
+          <p:cNvPr id="6" name="Rectangle: Rounded Corners 5">
+            <a:hlinkClick r:id="rId6" action="ppaction://hlinksldjump"/>
+            <a:extLst>
+              <a:ext uri="{FF2B5EF4-FFF2-40B4-BE49-F238E27FC236}">
+                <a16:creationId xmlns:a16="http://schemas.microsoft.com/office/drawing/2014/main" id="{784F8E44-C106-C933-636D-940F8CC9D075}"/>
+              </a:ext>
+            </a:extLst>
+          </p:cNvPr>
+          <p:cNvSpPr/>
+          <p:nvPr/>
+        </p:nvSpPr>
+        <p:spPr>
+          <a:xfrm>
+            <a:off x="11226800" y="107950"/>
+            <a:ext cx="812800" cy="317500"/>
+          </a:xfrm>
+          <a:prstGeom prst="roundRect">
+            <a:avLst/>
+          </a:prstGeom>
+        </p:spPr>
+        <p:style>
+          <a:lnRef idx="1">
+            <a:schemeClr val="accent4"/>
+          </a:lnRef>
+          <a:fillRef idx="2">
+            <a:schemeClr val="accent4"/>
+          </a:fillRef>
+          <a:effectRef idx="1">
+            <a:schemeClr val="accent4"/>
+          </a:effectRef>
+          <a:fontRef idx="minor">
+            <a:schemeClr val="dk1"/>
+          </a:fontRef>
+        </p:style>
+        <p:txBody>
+          <a:bodyPr rtlCol="0" anchor="ctr"/>
+          <a:lstStyle/>
+          <a:p>
+            <a:pPr algn="ctr"/>
+            <a:r>
+              <a:rPr lang="en-US" sz="1200" dirty="0"/>
+              <a:t>HOME</a:t>
+            </a:r>
+          </a:p>
+        </p:txBody>
+      </p:sp>
     </p:spTree>
     <p:extLst>
       <p:ext uri="{BB962C8B-B14F-4D97-AF65-F5344CB8AC3E}">
@@ -5472,7 +6276,7 @@
 </p:sld>
 </file>
 
-<file path=ppt/slides/slide14.xml><?xml version="1.0" encoding="utf-8"?>
+<file path=ppt/slides/slide17.xml><?xml version="1.0" encoding="utf-8"?>
 <p:sld xmlns:a="http://schemas.openxmlformats.org/drawingml/2006/main" xmlns:r="http://schemas.openxmlformats.org/officeDocument/2006/relationships" xmlns:p="http://schemas.openxmlformats.org/presentationml/2006/main">
   <p:cSld>
     <p:spTree>
@@ -5634,6 +6438,54 @@
           </a:prstGeom>
         </p:spPr>
       </p:pic>
+      <p:sp>
+        <p:nvSpPr>
+          <p:cNvPr id="5" name="Rectangle: Rounded Corners 4">
+            <a:hlinkClick r:id="rId5" action="ppaction://hlinksldjump"/>
+            <a:extLst>
+              <a:ext uri="{FF2B5EF4-FFF2-40B4-BE49-F238E27FC236}">
+                <a16:creationId xmlns:a16="http://schemas.microsoft.com/office/drawing/2014/main" id="{F6D651D1-A905-747C-50C2-297FDA3651BC}"/>
+              </a:ext>
+            </a:extLst>
+          </p:cNvPr>
+          <p:cNvSpPr/>
+          <p:nvPr/>
+        </p:nvSpPr>
+        <p:spPr>
+          <a:xfrm>
+            <a:off x="11226800" y="107950"/>
+            <a:ext cx="812800" cy="317500"/>
+          </a:xfrm>
+          <a:prstGeom prst="roundRect">
+            <a:avLst/>
+          </a:prstGeom>
+        </p:spPr>
+        <p:style>
+          <a:lnRef idx="1">
+            <a:schemeClr val="accent4"/>
+          </a:lnRef>
+          <a:fillRef idx="2">
+            <a:schemeClr val="accent4"/>
+          </a:fillRef>
+          <a:effectRef idx="1">
+            <a:schemeClr val="accent4"/>
+          </a:effectRef>
+          <a:fontRef idx="minor">
+            <a:schemeClr val="dk1"/>
+          </a:fontRef>
+        </p:style>
+        <p:txBody>
+          <a:bodyPr rtlCol="0" anchor="ctr"/>
+          <a:lstStyle/>
+          <a:p>
+            <a:pPr algn="ctr"/>
+            <a:r>
+              <a:rPr lang="en-US" sz="1200" dirty="0"/>
+              <a:t>HOME</a:t>
+            </a:r>
+          </a:p>
+        </p:txBody>
+      </p:sp>
     </p:spTree>
     <p:extLst>
       <p:ext uri="{BB962C8B-B14F-4D97-AF65-F5344CB8AC3E}">
@@ -5647,7 +6499,7 @@
 </p:sld>
 </file>
 
-<file path=ppt/slides/slide15.xml><?xml version="1.0" encoding="utf-8"?>
+<file path=ppt/slides/slide18.xml><?xml version="1.0" encoding="utf-8"?>
 <p:sld xmlns:a="http://schemas.openxmlformats.org/drawingml/2006/main" xmlns:r="http://schemas.openxmlformats.org/officeDocument/2006/relationships" xmlns:p="http://schemas.openxmlformats.org/presentationml/2006/main">
   <p:cSld>
     <p:spTree>
@@ -5914,6 +6766,54 @@
           </a:p>
         </p:txBody>
       </p:sp>
+      <p:sp>
+        <p:nvSpPr>
+          <p:cNvPr id="5" name="Rectangle: Rounded Corners 4">
+            <a:hlinkClick r:id="rId3" action="ppaction://hlinksldjump"/>
+            <a:extLst>
+              <a:ext uri="{FF2B5EF4-FFF2-40B4-BE49-F238E27FC236}">
+                <a16:creationId xmlns:a16="http://schemas.microsoft.com/office/drawing/2014/main" id="{681F216E-19F5-8B11-7554-FC212FCB2C1D}"/>
+              </a:ext>
+            </a:extLst>
+          </p:cNvPr>
+          <p:cNvSpPr/>
+          <p:nvPr/>
+        </p:nvSpPr>
+        <p:spPr>
+          <a:xfrm>
+            <a:off x="11226800" y="107950"/>
+            <a:ext cx="812800" cy="317500"/>
+          </a:xfrm>
+          <a:prstGeom prst="roundRect">
+            <a:avLst/>
+          </a:prstGeom>
+        </p:spPr>
+        <p:style>
+          <a:lnRef idx="1">
+            <a:schemeClr val="accent4"/>
+          </a:lnRef>
+          <a:fillRef idx="2">
+            <a:schemeClr val="accent4"/>
+          </a:fillRef>
+          <a:effectRef idx="1">
+            <a:schemeClr val="accent4"/>
+          </a:effectRef>
+          <a:fontRef idx="minor">
+            <a:schemeClr val="dk1"/>
+          </a:fontRef>
+        </p:style>
+        <p:txBody>
+          <a:bodyPr rtlCol="0" anchor="ctr"/>
+          <a:lstStyle/>
+          <a:p>
+            <a:pPr algn="ctr"/>
+            <a:r>
+              <a:rPr lang="en-US" sz="1200" dirty="0"/>
+              <a:t>HOME</a:t>
+            </a:r>
+          </a:p>
+        </p:txBody>
+      </p:sp>
     </p:spTree>
     <p:extLst>
       <p:ext uri="{BB962C8B-B14F-4D97-AF65-F5344CB8AC3E}">
@@ -5927,7 +6827,7 @@
 </p:sld>
 </file>
 
-<file path=ppt/slides/slide16.xml><?xml version="1.0" encoding="utf-8"?>
+<file path=ppt/slides/slide19.xml><?xml version="1.0" encoding="utf-8"?>
 <p:sld xmlns:a="http://schemas.openxmlformats.org/drawingml/2006/main" xmlns:r="http://schemas.openxmlformats.org/officeDocument/2006/relationships" xmlns:p="http://schemas.openxmlformats.org/presentationml/2006/main">
   <p:cSld>
     <p:spTree>
@@ -6194,297 +7094,58 @@
           </a:p>
         </p:txBody>
       </p:sp>
+      <p:sp>
+        <p:nvSpPr>
+          <p:cNvPr id="5" name="Rectangle: Rounded Corners 4">
+            <a:hlinkClick r:id="rId3" action="ppaction://hlinksldjump"/>
+            <a:extLst>
+              <a:ext uri="{FF2B5EF4-FFF2-40B4-BE49-F238E27FC236}">
+                <a16:creationId xmlns:a16="http://schemas.microsoft.com/office/drawing/2014/main" id="{8F824D12-E9C9-DE8F-8E6F-DC7C64761444}"/>
+              </a:ext>
+            </a:extLst>
+          </p:cNvPr>
+          <p:cNvSpPr/>
+          <p:nvPr/>
+        </p:nvSpPr>
+        <p:spPr>
+          <a:xfrm>
+            <a:off x="11226800" y="107950"/>
+            <a:ext cx="812800" cy="317500"/>
+          </a:xfrm>
+          <a:prstGeom prst="roundRect">
+            <a:avLst/>
+          </a:prstGeom>
+        </p:spPr>
+        <p:style>
+          <a:lnRef idx="1">
+            <a:schemeClr val="accent4"/>
+          </a:lnRef>
+          <a:fillRef idx="2">
+            <a:schemeClr val="accent4"/>
+          </a:fillRef>
+          <a:effectRef idx="1">
+            <a:schemeClr val="accent4"/>
+          </a:effectRef>
+          <a:fontRef idx="minor">
+            <a:schemeClr val="dk1"/>
+          </a:fontRef>
+        </p:style>
+        <p:txBody>
+          <a:bodyPr rtlCol="0" anchor="ctr"/>
+          <a:lstStyle/>
+          <a:p>
+            <a:pPr algn="ctr"/>
+            <a:r>
+              <a:rPr lang="en-US" sz="1200" dirty="0"/>
+              <a:t>HOME</a:t>
+            </a:r>
+          </a:p>
+        </p:txBody>
+      </p:sp>
     </p:spTree>
     <p:extLst>
       <p:ext uri="{BB962C8B-B14F-4D97-AF65-F5344CB8AC3E}">
         <p14:creationId xmlns:p14="http://schemas.microsoft.com/office/powerpoint/2010/main" val="3382225106"/>
-      </p:ext>
-    </p:extLst>
-  </p:cSld>
-  <p:clrMapOvr>
-    <a:masterClrMapping/>
-  </p:clrMapOvr>
-</p:sld>
-</file>
-
-<file path=ppt/slides/slide17.xml><?xml version="1.0" encoding="utf-8"?>
-<p:sld xmlns:a="http://schemas.openxmlformats.org/drawingml/2006/main" xmlns:r="http://schemas.openxmlformats.org/officeDocument/2006/relationships" xmlns:p="http://schemas.openxmlformats.org/presentationml/2006/main">
-  <p:cSld>
-    <p:spTree>
-      <p:nvGrpSpPr>
-        <p:cNvPr id="1" name=""/>
-        <p:cNvGrpSpPr/>
-        <p:nvPr/>
-      </p:nvGrpSpPr>
-      <p:grpSpPr>
-        <a:xfrm>
-          <a:off x="0" y="0"/>
-          <a:ext cx="0" cy="0"/>
-          <a:chOff x="0" y="0"/>
-          <a:chExt cx="0" cy="0"/>
-        </a:xfrm>
-      </p:grpSpPr>
-      <p:sp>
-        <p:nvSpPr>
-          <p:cNvPr id="2" name="Title 1">
-            <a:extLst>
-              <a:ext uri="{FF2B5EF4-FFF2-40B4-BE49-F238E27FC236}">
-                <a16:creationId xmlns:a16="http://schemas.microsoft.com/office/drawing/2014/main" id="{10927693-D745-3BDF-31B8-24FFC7F227CE}"/>
-              </a:ext>
-            </a:extLst>
-          </p:cNvPr>
-          <p:cNvSpPr>
-            <a:spLocks noGrp="1"/>
-          </p:cNvSpPr>
-          <p:nvPr>
-            <p:ph type="title"/>
-          </p:nvPr>
-        </p:nvSpPr>
-        <p:spPr/>
-        <p:txBody>
-          <a:bodyPr/>
-          <a:lstStyle/>
-          <a:p>
-            <a:r>
-              <a:rPr lang="en-US" dirty="0"/>
-              <a:t>Connecting to DataWrangling2025 SQL Server through R (cont.)</a:t>
-            </a:r>
-          </a:p>
-        </p:txBody>
-      </p:sp>
-      <p:sp>
-        <p:nvSpPr>
-          <p:cNvPr id="3" name="Content Placeholder 2">
-            <a:extLst>
-              <a:ext uri="{FF2B5EF4-FFF2-40B4-BE49-F238E27FC236}">
-                <a16:creationId xmlns:a16="http://schemas.microsoft.com/office/drawing/2014/main" id="{339C2077-1FB3-00F3-5B68-A32F1F4C9C39}"/>
-              </a:ext>
-            </a:extLst>
-          </p:cNvPr>
-          <p:cNvSpPr>
-            <a:spLocks noGrp="1"/>
-          </p:cNvSpPr>
-          <p:nvPr>
-            <p:ph idx="1"/>
-          </p:nvPr>
-        </p:nvSpPr>
-        <p:spPr>
-          <a:xfrm>
-            <a:off x="838200" y="1825625"/>
-            <a:ext cx="5458838" cy="4351338"/>
-          </a:xfrm>
-        </p:spPr>
-        <p:txBody>
-          <a:bodyPr/>
-          <a:lstStyle/>
-          <a:p>
-            <a:r>
-              <a:rPr lang="en-US" dirty="0"/>
-              <a:t>Run </a:t>
-            </a:r>
-            <a:r>
-              <a:rPr lang="en-US" dirty="0" err="1"/>
-              <a:t>test_sql.R</a:t>
-            </a:r>
-            <a:r>
-              <a:rPr lang="en-US" dirty="0"/>
-              <a:t> in RStudio on your laptop</a:t>
-            </a:r>
-          </a:p>
-          <a:p>
-            <a:r>
-              <a:rPr lang="en-US" dirty="0"/>
-              <a:t>See next slide for the expected output</a:t>
-            </a:r>
-          </a:p>
-          <a:p>
-            <a:r>
-              <a:rPr lang="en-US" dirty="0"/>
-              <a:t>If you do not see the expected outputs, email </a:t>
-            </a:r>
-            <a:r>
-              <a:rPr lang="en-US" dirty="0">
-                <a:hlinkClick r:id="rId3"/>
-              </a:rPr>
-              <a:t>Yichen.chen@stjude.org</a:t>
-            </a:r>
-            <a:r>
-              <a:rPr lang="en-US" dirty="0"/>
-              <a:t> with screenshot</a:t>
-            </a:r>
-          </a:p>
-          <a:p>
-            <a:endParaRPr lang="en-US" dirty="0"/>
-          </a:p>
-          <a:p>
-            <a:pPr marL="0" indent="0">
-              <a:buNone/>
-            </a:pPr>
-            <a:endParaRPr lang="en-US" dirty="0"/>
-          </a:p>
-        </p:txBody>
-      </p:sp>
-      <p:pic>
-        <p:nvPicPr>
-          <p:cNvPr id="5" name="Picture 4">
-            <a:extLst>
-              <a:ext uri="{FF2B5EF4-FFF2-40B4-BE49-F238E27FC236}">
-                <a16:creationId xmlns:a16="http://schemas.microsoft.com/office/drawing/2014/main" id="{25185061-4D27-3780-4E86-3165FA12BB49}"/>
-              </a:ext>
-            </a:extLst>
-          </p:cNvPr>
-          <p:cNvPicPr>
-            <a:picLocks noChangeAspect="1"/>
-          </p:cNvPicPr>
-          <p:nvPr/>
-        </p:nvPicPr>
-        <p:blipFill>
-          <a:blip r:embed="rId4"/>
-          <a:stretch>
-            <a:fillRect/>
-          </a:stretch>
-        </p:blipFill>
-        <p:spPr>
-          <a:xfrm>
-            <a:off x="6011662" y="2605624"/>
-            <a:ext cx="6034844" cy="1998802"/>
-          </a:xfrm>
-          <a:prstGeom prst="rect">
-            <a:avLst/>
-          </a:prstGeom>
-        </p:spPr>
-      </p:pic>
-    </p:spTree>
-    <p:extLst>
-      <p:ext uri="{BB962C8B-B14F-4D97-AF65-F5344CB8AC3E}">
-        <p14:creationId xmlns:p14="http://schemas.microsoft.com/office/powerpoint/2010/main" val="4066761548"/>
-      </p:ext>
-    </p:extLst>
-  </p:cSld>
-  <p:clrMapOvr>
-    <a:masterClrMapping/>
-  </p:clrMapOvr>
-</p:sld>
-</file>
-
-<file path=ppt/slides/slide18.xml><?xml version="1.0" encoding="utf-8"?>
-<p:sld xmlns:a="http://schemas.openxmlformats.org/drawingml/2006/main" xmlns:r="http://schemas.openxmlformats.org/officeDocument/2006/relationships" xmlns:p="http://schemas.openxmlformats.org/presentationml/2006/main">
-  <p:cSld>
-    <p:spTree>
-      <p:nvGrpSpPr>
-        <p:cNvPr id="1" name=""/>
-        <p:cNvGrpSpPr/>
-        <p:nvPr/>
-      </p:nvGrpSpPr>
-      <p:grpSpPr>
-        <a:xfrm>
-          <a:off x="0" y="0"/>
-          <a:ext cx="0" cy="0"/>
-          <a:chOff x="0" y="0"/>
-          <a:chExt cx="0" cy="0"/>
-        </a:xfrm>
-      </p:grpSpPr>
-      <p:sp>
-        <p:nvSpPr>
-          <p:cNvPr id="2" name="Title 1">
-            <a:extLst>
-              <a:ext uri="{FF2B5EF4-FFF2-40B4-BE49-F238E27FC236}">
-                <a16:creationId xmlns:a16="http://schemas.microsoft.com/office/drawing/2014/main" id="{8D11D081-7BE2-42A5-C702-0BCAA09C178D}"/>
-              </a:ext>
-            </a:extLst>
-          </p:cNvPr>
-          <p:cNvSpPr>
-            <a:spLocks noGrp="1"/>
-          </p:cNvSpPr>
-          <p:nvPr>
-            <p:ph type="title"/>
-          </p:nvPr>
-        </p:nvSpPr>
-        <p:spPr/>
-        <p:txBody>
-          <a:bodyPr/>
-          <a:lstStyle/>
-          <a:p>
-            <a:r>
-              <a:rPr lang="en-US" dirty="0"/>
-              <a:t>Connecting to DataWrangling2025 SQL Server through R (cont.)</a:t>
-            </a:r>
-          </a:p>
-        </p:txBody>
-      </p:sp>
-      <p:sp>
-        <p:nvSpPr>
-          <p:cNvPr id="3" name="Content Placeholder 2">
-            <a:extLst>
-              <a:ext uri="{FF2B5EF4-FFF2-40B4-BE49-F238E27FC236}">
-                <a16:creationId xmlns:a16="http://schemas.microsoft.com/office/drawing/2014/main" id="{00EE931D-4331-A9AC-C48A-852E5967BEE4}"/>
-              </a:ext>
-            </a:extLst>
-          </p:cNvPr>
-          <p:cNvSpPr>
-            <a:spLocks noGrp="1"/>
-          </p:cNvSpPr>
-          <p:nvPr>
-            <p:ph idx="1"/>
-          </p:nvPr>
-        </p:nvSpPr>
-        <p:spPr/>
-        <p:txBody>
-          <a:bodyPr/>
-          <a:lstStyle/>
-          <a:p>
-            <a:r>
-              <a:rPr lang="en-US" dirty="0"/>
-              <a:t>Expected output from </a:t>
-            </a:r>
-            <a:r>
-              <a:rPr lang="en-US" dirty="0" err="1"/>
-              <a:t>test_sql.R</a:t>
-            </a:r>
-            <a:endParaRPr lang="en-US" dirty="0"/>
-          </a:p>
-          <a:p>
-            <a:endParaRPr lang="en-US" dirty="0"/>
-          </a:p>
-          <a:p>
-            <a:endParaRPr lang="en-US" dirty="0"/>
-          </a:p>
-        </p:txBody>
-      </p:sp>
-      <p:pic>
-        <p:nvPicPr>
-          <p:cNvPr id="8" name="Picture 7">
-            <a:extLst>
-              <a:ext uri="{FF2B5EF4-FFF2-40B4-BE49-F238E27FC236}">
-                <a16:creationId xmlns:a16="http://schemas.microsoft.com/office/drawing/2014/main" id="{9760AB8A-0B3C-B8DB-0CD0-B3CD1C11D836}"/>
-              </a:ext>
-            </a:extLst>
-          </p:cNvPr>
-          <p:cNvPicPr>
-            <a:picLocks noChangeAspect="1"/>
-          </p:cNvPicPr>
-          <p:nvPr/>
-        </p:nvPicPr>
-        <p:blipFill>
-          <a:blip r:embed="rId2"/>
-          <a:stretch>
-            <a:fillRect/>
-          </a:stretch>
-        </p:blipFill>
-        <p:spPr>
-          <a:xfrm>
-            <a:off x="2848831" y="2435195"/>
-            <a:ext cx="6494337" cy="4157044"/>
-          </a:xfrm>
-          <a:prstGeom prst="rect">
-            <a:avLst/>
-          </a:prstGeom>
-        </p:spPr>
-      </p:pic>
-    </p:spTree>
-    <p:extLst>
-      <p:ext uri="{BB962C8B-B14F-4D97-AF65-F5344CB8AC3E}">
-        <p14:creationId xmlns:p14="http://schemas.microsoft.com/office/powerpoint/2010/main" val="3156994839"/>
       </p:ext>
     </p:extLst>
   </p:cSld>
@@ -6534,7 +7195,7 @@
           <a:p>
             <a:r>
               <a:rPr lang="en-US" dirty="0"/>
-              <a:t>SQL Connection Testing	</a:t>
+              <a:t>SQL Server	</a:t>
             </a:r>
           </a:p>
         </p:txBody>
@@ -6557,80 +7218,62 @@
         </p:nvSpPr>
         <p:spPr/>
         <p:txBody>
-          <a:bodyPr/>
+          <a:bodyPr>
+            <a:normAutofit/>
+          </a:bodyPr>
           <a:lstStyle/>
           <a:p>
             <a:r>
               <a:rPr lang="en-US" dirty="0"/>
-              <a:t>Connecting to DataWrangling2025 SQL Server through SSMS</a:t>
+              <a:t>SQL Server: DataWrangling2025</a:t>
             </a:r>
           </a:p>
           <a:p>
             <a:r>
               <a:rPr lang="en-US" dirty="0"/>
-              <a:t>Repository </a:t>
-            </a:r>
+              <a:t>Three Databases</a:t>
+            </a:r>
+          </a:p>
+          <a:p>
+            <a:pPr lvl="1"/>
             <a:r>
               <a:rPr lang="en-US" dirty="0" err="1"/>
-              <a:t>DataWrangling_R</a:t>
+              <a:t>datawrangling_R</a:t>
             </a:r>
             <a:r>
               <a:rPr lang="en-US" dirty="0"/>
-              <a:t> in St. Jude MS ABDS, </a:t>
-            </a:r>
+              <a:t> (DSN: DW_R)</a:t>
+            </a:r>
+          </a:p>
+          <a:p>
+            <a:pPr lvl="1"/>
             <a:r>
               <a:rPr lang="en-US" dirty="0" err="1"/>
-              <a:t>Github</a:t>
-            </a:r>
+              <a:t>datawrangling_SQL</a:t>
+            </a:r>
+            <a:r>
+              <a:rPr lang="en-US" dirty="0"/>
+              <a:t> (DSN: DW_SQL)</a:t>
+            </a:r>
+          </a:p>
+          <a:p>
+            <a:pPr lvl="1"/>
+            <a:r>
+              <a:rPr lang="en-US" dirty="0" err="1"/>
+              <a:t>ccs_applications</a:t>
+            </a:r>
+            <a:r>
+              <a:rPr lang="en-US" dirty="0"/>
+              <a:t> (DSN: DW_CCS)</a:t>
+            </a:r>
+          </a:p>
+          <a:p>
+            <a:pPr lvl="1"/>
             <a:endParaRPr lang="en-US" dirty="0"/>
           </a:p>
           <a:p>
-            <a:r>
-              <a:rPr lang="en-US" dirty="0"/>
-              <a:t>Connecting to DataWrangling2025 SQL Server through SAS Server</a:t>
-            </a:r>
-          </a:p>
-          <a:p>
             <a:pPr lvl="1"/>
-            <a:r>
-              <a:rPr lang="en-US" dirty="0"/>
-              <a:t>Using data source name (DSN)</a:t>
-            </a:r>
-          </a:p>
-          <a:p>
-            <a:pPr lvl="1"/>
-            <a:r>
-              <a:rPr lang="en-US" dirty="0"/>
-              <a:t>Using proc </a:t>
-            </a:r>
-            <a:r>
-              <a:rPr lang="en-US" dirty="0" err="1"/>
-              <a:t>sql</a:t>
-            </a:r>
-            <a:r>
-              <a:rPr lang="en-US" dirty="0"/>
-              <a:t>  </a:t>
-            </a:r>
-          </a:p>
-          <a:p>
-            <a:r>
-              <a:rPr lang="en-US" dirty="0"/>
-              <a:t>Connecting to DataWrangling2025 SQL Server through R</a:t>
-            </a:r>
-          </a:p>
-          <a:p>
-            <a:pPr lvl="1"/>
-            <a:r>
-              <a:rPr lang="en-US" dirty="0"/>
-              <a:t>Adding DSN into Windows OS</a:t>
-            </a:r>
-          </a:p>
-          <a:p>
-            <a:pPr lvl="1"/>
-            <a:r>
-              <a:rPr lang="en-US" dirty="0"/>
-              <a:t>Using DSN</a:t>
-            </a:r>
+            <a:endParaRPr lang="en-US" dirty="0"/>
           </a:p>
         </p:txBody>
       </p:sp>
@@ -6647,7 +7290,7 @@
 </p:sld>
 </file>
 
-<file path=ppt/slides/slide3.xml><?xml version="1.0" encoding="utf-8"?>
+<file path=ppt/slides/slide20.xml><?xml version="1.0" encoding="utf-8"?>
 <p:sld xmlns:a="http://schemas.openxmlformats.org/drawingml/2006/main" xmlns:r="http://schemas.openxmlformats.org/officeDocument/2006/relationships" xmlns:p="http://schemas.openxmlformats.org/presentationml/2006/main">
   <p:cSld>
     <p:spTree>
@@ -6669,7 +7312,7 @@
           <p:cNvPr id="2" name="Title 1">
             <a:extLst>
               <a:ext uri="{FF2B5EF4-FFF2-40B4-BE49-F238E27FC236}">
-                <a16:creationId xmlns:a16="http://schemas.microsoft.com/office/drawing/2014/main" id="{844D4D66-3814-B138-AF30-A282C61B0C51}"/>
+                <a16:creationId xmlns:a16="http://schemas.microsoft.com/office/drawing/2014/main" id="{10927693-D745-3BDF-31B8-24FFC7F227CE}"/>
               </a:ext>
             </a:extLst>
           </p:cNvPr>
@@ -6687,7 +7330,7 @@
           <a:p>
             <a:r>
               <a:rPr lang="en-US" dirty="0"/>
-              <a:t>Connecting to DataWrangling2025 SQL Server through SSMS</a:t>
+              <a:t>Connecting to DataWrangling2025 SQL Server through R (cont.)</a:t>
             </a:r>
           </a:p>
         </p:txBody>
@@ -6697,7 +7340,7 @@
           <p:cNvPr id="3" name="Content Placeholder 2">
             <a:extLst>
               <a:ext uri="{FF2B5EF4-FFF2-40B4-BE49-F238E27FC236}">
-                <a16:creationId xmlns:a16="http://schemas.microsoft.com/office/drawing/2014/main" id="{451AC857-3F7E-F462-8D54-A1A4E4550545}"/>
+                <a16:creationId xmlns:a16="http://schemas.microsoft.com/office/drawing/2014/main" id="{339C2077-1FB3-00F3-5B68-A32F1F4C9C39}"/>
               </a:ext>
             </a:extLst>
           </p:cNvPr>
@@ -6708,25 +7351,53 @@
             <p:ph idx="1"/>
           </p:nvPr>
         </p:nvSpPr>
-        <p:spPr/>
+        <p:spPr>
+          <a:xfrm>
+            <a:off x="838200" y="1825625"/>
+            <a:ext cx="5458838" cy="4351338"/>
+          </a:xfrm>
+        </p:spPr>
         <p:txBody>
           <a:bodyPr/>
           <a:lstStyle/>
           <a:p>
             <a:r>
               <a:rPr lang="en-US" dirty="0"/>
-              <a:t>Install SSMS (</a:t>
+              <a:t>Run </a:t>
+            </a:r>
+            <a:r>
+              <a:rPr lang="en-US" dirty="0" err="1"/>
+              <a:t>test_sql.R</a:t>
+            </a:r>
+            <a:r>
+              <a:rPr lang="en-US" dirty="0"/>
+              <a:t> in RStudio on your laptop</a:t>
+            </a:r>
+          </a:p>
+          <a:p>
+            <a:r>
+              <a:rPr lang="en-US" dirty="0"/>
+              <a:t>See next slide for the expected output</a:t>
+            </a:r>
+          </a:p>
+          <a:p>
+            <a:r>
+              <a:rPr lang="en-US" dirty="0"/>
+              <a:t>If you do not see the expected outputs, email </a:t>
             </a:r>
             <a:r>
               <a:rPr lang="en-US" dirty="0">
-                <a:hlinkClick r:id="rId2"/>
+                <a:hlinkClick r:id="rId3"/>
               </a:rPr>
-              <a:t>https://learn.microsoft.com/en-us/ssms/install/install</a:t>
+              <a:t>Yichen.chen@stjude.org</a:t>
             </a:r>
             <a:r>
               <a:rPr lang="en-US" dirty="0"/>
-              <a:t>)</a:t>
-            </a:r>
+              <a:t> with screenshot</a:t>
+            </a:r>
+          </a:p>
+          <a:p>
+            <a:endParaRPr lang="en-US" dirty="0"/>
           </a:p>
           <a:p>
             <a:pPr marL="0" indent="0">
@@ -6741,7 +7412,7 @@
           <p:cNvPr id="5" name="Picture 4">
             <a:extLst>
               <a:ext uri="{FF2B5EF4-FFF2-40B4-BE49-F238E27FC236}">
-                <a16:creationId xmlns:a16="http://schemas.microsoft.com/office/drawing/2014/main" id="{7238E87F-990D-D5A1-9573-6B5FEA69EBF1}"/>
+                <a16:creationId xmlns:a16="http://schemas.microsoft.com/office/drawing/2014/main" id="{25185061-4D27-3780-4E86-3165FA12BB49}"/>
               </a:ext>
             </a:extLst>
           </p:cNvPr>
@@ -6751,25 +7422,415 @@
           <p:nvPr/>
         </p:nvPicPr>
         <p:blipFill>
-          <a:blip r:embed="rId3"/>
+          <a:blip r:embed="rId4"/>
           <a:stretch>
             <a:fillRect/>
           </a:stretch>
         </p:blipFill>
         <p:spPr>
           <a:xfrm>
-            <a:off x="2801565" y="2907206"/>
-            <a:ext cx="4997015" cy="3325242"/>
+            <a:off x="6011662" y="2605624"/>
+            <a:ext cx="6034844" cy="1998802"/>
           </a:xfrm>
           <a:prstGeom prst="rect">
             <a:avLst/>
           </a:prstGeom>
         </p:spPr>
       </p:pic>
+      <p:sp>
+        <p:nvSpPr>
+          <p:cNvPr id="6" name="Rectangle: Rounded Corners 5">
+            <a:hlinkClick r:id="rId5" action="ppaction://hlinksldjump"/>
+            <a:extLst>
+              <a:ext uri="{FF2B5EF4-FFF2-40B4-BE49-F238E27FC236}">
+                <a16:creationId xmlns:a16="http://schemas.microsoft.com/office/drawing/2014/main" id="{7F7BF8C9-3D9F-6551-130B-1C0E96261142}"/>
+              </a:ext>
+            </a:extLst>
+          </p:cNvPr>
+          <p:cNvSpPr/>
+          <p:nvPr/>
+        </p:nvSpPr>
+        <p:spPr>
+          <a:xfrm>
+            <a:off x="11226800" y="107950"/>
+            <a:ext cx="812800" cy="317500"/>
+          </a:xfrm>
+          <a:prstGeom prst="roundRect">
+            <a:avLst/>
+          </a:prstGeom>
+        </p:spPr>
+        <p:style>
+          <a:lnRef idx="1">
+            <a:schemeClr val="accent4"/>
+          </a:lnRef>
+          <a:fillRef idx="2">
+            <a:schemeClr val="accent4"/>
+          </a:fillRef>
+          <a:effectRef idx="1">
+            <a:schemeClr val="accent4"/>
+          </a:effectRef>
+          <a:fontRef idx="minor">
+            <a:schemeClr val="dk1"/>
+          </a:fontRef>
+        </p:style>
+        <p:txBody>
+          <a:bodyPr rtlCol="0" anchor="ctr"/>
+          <a:lstStyle/>
+          <a:p>
+            <a:pPr algn="ctr"/>
+            <a:r>
+              <a:rPr lang="en-US" sz="1200" dirty="0"/>
+              <a:t>HOME</a:t>
+            </a:r>
+          </a:p>
+        </p:txBody>
+      </p:sp>
     </p:spTree>
     <p:extLst>
       <p:ext uri="{BB962C8B-B14F-4D97-AF65-F5344CB8AC3E}">
-        <p14:creationId xmlns:p14="http://schemas.microsoft.com/office/powerpoint/2010/main" val="3333290551"/>
+        <p14:creationId xmlns:p14="http://schemas.microsoft.com/office/powerpoint/2010/main" val="4066761548"/>
+      </p:ext>
+    </p:extLst>
+  </p:cSld>
+  <p:clrMapOvr>
+    <a:masterClrMapping/>
+  </p:clrMapOvr>
+</p:sld>
+</file>
+
+<file path=ppt/slides/slide21.xml><?xml version="1.0" encoding="utf-8"?>
+<p:sld xmlns:a="http://schemas.openxmlformats.org/drawingml/2006/main" xmlns:r="http://schemas.openxmlformats.org/officeDocument/2006/relationships" xmlns:p="http://schemas.openxmlformats.org/presentationml/2006/main">
+  <p:cSld>
+    <p:spTree>
+      <p:nvGrpSpPr>
+        <p:cNvPr id="1" name=""/>
+        <p:cNvGrpSpPr/>
+        <p:nvPr/>
+      </p:nvGrpSpPr>
+      <p:grpSpPr>
+        <a:xfrm>
+          <a:off x="0" y="0"/>
+          <a:ext cx="0" cy="0"/>
+          <a:chOff x="0" y="0"/>
+          <a:chExt cx="0" cy="0"/>
+        </a:xfrm>
+      </p:grpSpPr>
+      <p:sp>
+        <p:nvSpPr>
+          <p:cNvPr id="2" name="Title 1">
+            <a:extLst>
+              <a:ext uri="{FF2B5EF4-FFF2-40B4-BE49-F238E27FC236}">
+                <a16:creationId xmlns:a16="http://schemas.microsoft.com/office/drawing/2014/main" id="{8D11D081-7BE2-42A5-C702-0BCAA09C178D}"/>
+              </a:ext>
+            </a:extLst>
+          </p:cNvPr>
+          <p:cNvSpPr>
+            <a:spLocks noGrp="1"/>
+          </p:cNvSpPr>
+          <p:nvPr>
+            <p:ph type="title"/>
+          </p:nvPr>
+        </p:nvSpPr>
+        <p:spPr/>
+        <p:txBody>
+          <a:bodyPr/>
+          <a:lstStyle/>
+          <a:p>
+            <a:r>
+              <a:rPr lang="en-US" dirty="0"/>
+              <a:t>Connecting to DataWrangling2025 SQL Server through R (cont.)</a:t>
+            </a:r>
+          </a:p>
+        </p:txBody>
+      </p:sp>
+      <p:sp>
+        <p:nvSpPr>
+          <p:cNvPr id="3" name="Content Placeholder 2">
+            <a:extLst>
+              <a:ext uri="{FF2B5EF4-FFF2-40B4-BE49-F238E27FC236}">
+                <a16:creationId xmlns:a16="http://schemas.microsoft.com/office/drawing/2014/main" id="{00EE931D-4331-A9AC-C48A-852E5967BEE4}"/>
+              </a:ext>
+            </a:extLst>
+          </p:cNvPr>
+          <p:cNvSpPr>
+            <a:spLocks noGrp="1"/>
+          </p:cNvSpPr>
+          <p:nvPr>
+            <p:ph idx="1"/>
+          </p:nvPr>
+        </p:nvSpPr>
+        <p:spPr/>
+        <p:txBody>
+          <a:bodyPr/>
+          <a:lstStyle/>
+          <a:p>
+            <a:r>
+              <a:rPr lang="en-US" dirty="0"/>
+              <a:t>Expected output from </a:t>
+            </a:r>
+            <a:r>
+              <a:rPr lang="en-US" dirty="0" err="1"/>
+              <a:t>test_sql.R</a:t>
+            </a:r>
+            <a:endParaRPr lang="en-US" dirty="0"/>
+          </a:p>
+          <a:p>
+            <a:endParaRPr lang="en-US" dirty="0"/>
+          </a:p>
+          <a:p>
+            <a:endParaRPr lang="en-US" dirty="0"/>
+          </a:p>
+        </p:txBody>
+      </p:sp>
+      <p:pic>
+        <p:nvPicPr>
+          <p:cNvPr id="8" name="Picture 7">
+            <a:extLst>
+              <a:ext uri="{FF2B5EF4-FFF2-40B4-BE49-F238E27FC236}">
+                <a16:creationId xmlns:a16="http://schemas.microsoft.com/office/drawing/2014/main" id="{9760AB8A-0B3C-B8DB-0CD0-B3CD1C11D836}"/>
+              </a:ext>
+            </a:extLst>
+          </p:cNvPr>
+          <p:cNvPicPr>
+            <a:picLocks noChangeAspect="1"/>
+          </p:cNvPicPr>
+          <p:nvPr/>
+        </p:nvPicPr>
+        <p:blipFill>
+          <a:blip r:embed="rId2"/>
+          <a:stretch>
+            <a:fillRect/>
+          </a:stretch>
+        </p:blipFill>
+        <p:spPr>
+          <a:xfrm>
+            <a:off x="2848831" y="2435195"/>
+            <a:ext cx="6494337" cy="4157044"/>
+          </a:xfrm>
+          <a:prstGeom prst="rect">
+            <a:avLst/>
+          </a:prstGeom>
+        </p:spPr>
+      </p:pic>
+      <p:sp>
+        <p:nvSpPr>
+          <p:cNvPr id="5" name="Rectangle: Rounded Corners 4">
+            <a:hlinkClick r:id="rId3" action="ppaction://hlinksldjump"/>
+            <a:extLst>
+              <a:ext uri="{FF2B5EF4-FFF2-40B4-BE49-F238E27FC236}">
+                <a16:creationId xmlns:a16="http://schemas.microsoft.com/office/drawing/2014/main" id="{931DBEE9-D99C-7070-B4AD-5A1E74F63639}"/>
+              </a:ext>
+            </a:extLst>
+          </p:cNvPr>
+          <p:cNvSpPr/>
+          <p:nvPr/>
+        </p:nvSpPr>
+        <p:spPr>
+          <a:xfrm>
+            <a:off x="11226800" y="107950"/>
+            <a:ext cx="812800" cy="317500"/>
+          </a:xfrm>
+          <a:prstGeom prst="roundRect">
+            <a:avLst/>
+          </a:prstGeom>
+        </p:spPr>
+        <p:style>
+          <a:lnRef idx="1">
+            <a:schemeClr val="accent4"/>
+          </a:lnRef>
+          <a:fillRef idx="2">
+            <a:schemeClr val="accent4"/>
+          </a:fillRef>
+          <a:effectRef idx="1">
+            <a:schemeClr val="accent4"/>
+          </a:effectRef>
+          <a:fontRef idx="minor">
+            <a:schemeClr val="dk1"/>
+          </a:fontRef>
+        </p:style>
+        <p:txBody>
+          <a:bodyPr rtlCol="0" anchor="ctr"/>
+          <a:lstStyle/>
+          <a:p>
+            <a:pPr algn="ctr"/>
+            <a:r>
+              <a:rPr lang="en-US" sz="1200" dirty="0"/>
+              <a:t>HOME</a:t>
+            </a:r>
+          </a:p>
+        </p:txBody>
+      </p:sp>
+    </p:spTree>
+    <p:extLst>
+      <p:ext uri="{BB962C8B-B14F-4D97-AF65-F5344CB8AC3E}">
+        <p14:creationId xmlns:p14="http://schemas.microsoft.com/office/powerpoint/2010/main" val="3156994839"/>
+      </p:ext>
+    </p:extLst>
+  </p:cSld>
+  <p:clrMapOvr>
+    <a:masterClrMapping/>
+  </p:clrMapOvr>
+</p:sld>
+</file>
+
+<file path=ppt/slides/slide3.xml><?xml version="1.0" encoding="utf-8"?>
+<p:sld xmlns:a="http://schemas.openxmlformats.org/drawingml/2006/main" xmlns:r="http://schemas.openxmlformats.org/officeDocument/2006/relationships" xmlns:p="http://schemas.openxmlformats.org/presentationml/2006/main">
+  <p:cSld>
+    <p:spTree>
+      <p:nvGrpSpPr>
+        <p:cNvPr id="1" name="">
+          <a:extLst>
+            <a:ext uri="{FF2B5EF4-FFF2-40B4-BE49-F238E27FC236}">
+              <a16:creationId xmlns:a16="http://schemas.microsoft.com/office/drawing/2014/main" id="{852D4442-5EA6-E1DD-99BB-272518EA3B63}"/>
+            </a:ext>
+          </a:extLst>
+        </p:cNvPr>
+        <p:cNvGrpSpPr/>
+        <p:nvPr/>
+      </p:nvGrpSpPr>
+      <p:grpSpPr>
+        <a:xfrm>
+          <a:off x="0" y="0"/>
+          <a:ext cx="0" cy="0"/>
+          <a:chOff x="0" y="0"/>
+          <a:chExt cx="0" cy="0"/>
+        </a:xfrm>
+      </p:grpSpPr>
+      <p:sp>
+        <p:nvSpPr>
+          <p:cNvPr id="2" name="Title 1">
+            <a:extLst>
+              <a:ext uri="{FF2B5EF4-FFF2-40B4-BE49-F238E27FC236}">
+                <a16:creationId xmlns:a16="http://schemas.microsoft.com/office/drawing/2014/main" id="{AB49B035-58B4-F5C9-C0F3-F8193E60B3DE}"/>
+              </a:ext>
+            </a:extLst>
+          </p:cNvPr>
+          <p:cNvSpPr>
+            <a:spLocks noGrp="1"/>
+          </p:cNvSpPr>
+          <p:nvPr>
+            <p:ph type="title"/>
+          </p:nvPr>
+        </p:nvSpPr>
+        <p:spPr/>
+        <p:txBody>
+          <a:bodyPr/>
+          <a:lstStyle/>
+          <a:p>
+            <a:r>
+              <a:rPr lang="en-US" dirty="0"/>
+              <a:t>SQL Connection Testing	</a:t>
+            </a:r>
+          </a:p>
+        </p:txBody>
+      </p:sp>
+      <p:sp>
+        <p:nvSpPr>
+          <p:cNvPr id="3" name="Content Placeholder 2">
+            <a:extLst>
+              <a:ext uri="{FF2B5EF4-FFF2-40B4-BE49-F238E27FC236}">
+                <a16:creationId xmlns:a16="http://schemas.microsoft.com/office/drawing/2014/main" id="{BD557029-C4F9-F71C-0013-75D01D817DC4}"/>
+              </a:ext>
+            </a:extLst>
+          </p:cNvPr>
+          <p:cNvSpPr>
+            <a:spLocks noGrp="1"/>
+          </p:cNvSpPr>
+          <p:nvPr>
+            <p:ph idx="1"/>
+          </p:nvPr>
+        </p:nvSpPr>
+        <p:spPr/>
+        <p:txBody>
+          <a:bodyPr>
+            <a:normAutofit/>
+          </a:bodyPr>
+          <a:lstStyle/>
+          <a:p>
+            <a:r>
+              <a:rPr lang="en-US" dirty="0"/>
+              <a:t>You should be able to connect to the DataWrangling2025 SQL Server using </a:t>
+            </a:r>
+            <a:r>
+              <a:rPr lang="en-US" i="1" u="sng" dirty="0"/>
+              <a:t>all</a:t>
+            </a:r>
+            <a:r>
+              <a:rPr lang="en-US" dirty="0"/>
+              <a:t> of the following methods:</a:t>
+            </a:r>
+          </a:p>
+          <a:p>
+            <a:pPr lvl="0"/>
+            <a:r>
+              <a:rPr lang="en-US" b="1" dirty="0">
+                <a:hlinkClick r:id="rId2" action="ppaction://hlinksldjump"/>
+              </a:rPr>
+              <a:t>SQL Server Management Studio (SSMS)</a:t>
+            </a:r>
+            <a:endParaRPr lang="en-US" dirty="0"/>
+          </a:p>
+          <a:p>
+            <a:pPr lvl="0"/>
+            <a:r>
+              <a:rPr lang="en-US" b="1" dirty="0">
+                <a:hlinkClick r:id="rId3" action="ppaction://hlinksldjump"/>
+              </a:rPr>
+              <a:t>SAS Server</a:t>
+            </a:r>
+            <a:endParaRPr lang="en-US" dirty="0"/>
+          </a:p>
+          <a:p>
+            <a:pPr lvl="1">
+              <a:buFont typeface="Courier New" panose="02070309020205020404" pitchFamily="49" charset="0"/>
+              <a:buChar char="o"/>
+            </a:pPr>
+            <a:r>
+              <a:rPr lang="en-US" dirty="0"/>
+              <a:t>Using a Data Source Name (DSN)</a:t>
+            </a:r>
+          </a:p>
+          <a:p>
+            <a:pPr lvl="1">
+              <a:buFont typeface="Courier New" panose="02070309020205020404" pitchFamily="49" charset="0"/>
+              <a:buChar char="o"/>
+            </a:pPr>
+            <a:r>
+              <a:rPr lang="en-US" dirty="0"/>
+              <a:t>Using PROC SQL</a:t>
+            </a:r>
+          </a:p>
+          <a:p>
+            <a:pPr lvl="0"/>
+            <a:r>
+              <a:rPr lang="en-US" b="1" dirty="0">
+                <a:hlinkClick r:id="rId4" action="ppaction://hlinksldjump"/>
+              </a:rPr>
+              <a:t>R</a:t>
+            </a:r>
+            <a:endParaRPr lang="en-US" dirty="0"/>
+          </a:p>
+          <a:p>
+            <a:pPr lvl="1">
+              <a:buFont typeface="Courier New" panose="02070309020205020404" pitchFamily="49" charset="0"/>
+              <a:buChar char="o"/>
+            </a:pPr>
+            <a:r>
+              <a:rPr lang="en-US" dirty="0"/>
+              <a:t>Using a Data Source Name (DSN) </a:t>
+            </a:r>
+            <a:r>
+              <a:rPr lang="en-US" i="1" dirty="0"/>
+              <a:t>(Prerequisite: Manually configure the ODBC driver and DSN on your computer.)</a:t>
+            </a:r>
+            <a:endParaRPr lang="en-US" dirty="0"/>
+          </a:p>
+        </p:txBody>
+      </p:sp>
+    </p:spTree>
+    <p:extLst>
+      <p:ext uri="{BB962C8B-B14F-4D97-AF65-F5344CB8AC3E}">
+        <p14:creationId xmlns:p14="http://schemas.microsoft.com/office/powerpoint/2010/main" val="1430948841"/>
       </p:ext>
     </p:extLst>
   </p:cSld>
@@ -6801,7 +7862,7 @@
           <p:cNvPr id="2" name="Title 1">
             <a:extLst>
               <a:ext uri="{FF2B5EF4-FFF2-40B4-BE49-F238E27FC236}">
-                <a16:creationId xmlns:a16="http://schemas.microsoft.com/office/drawing/2014/main" id="{BCF1CA1B-51A7-BEDF-9A15-299B5A07E8D2}"/>
+                <a16:creationId xmlns:a16="http://schemas.microsoft.com/office/drawing/2014/main" id="{F10D41B5-52DF-9A35-B4DA-B9F4C0E8AF78}"/>
               </a:ext>
             </a:extLst>
           </p:cNvPr>
@@ -6818,95 +7879,93 @@
           <a:lstStyle/>
           <a:p>
             <a:r>
+              <a:rPr lang="en-US" sz="4800" dirty="0"/>
+              <a:t>SQL Server Management Studio (SSMS)</a:t>
+            </a:r>
+            <a:br>
               <a:rPr lang="en-US" dirty="0"/>
-              <a:t>Connecting to DataWrangling2025 SQL Server through SSMS (cont.)</a:t>
-            </a:r>
-          </a:p>
-        </p:txBody>
-      </p:sp>
-      <p:sp>
-        <p:nvSpPr>
-          <p:cNvPr id="3" name="Content Placeholder 2">
-            <a:extLst>
-              <a:ext uri="{FF2B5EF4-FFF2-40B4-BE49-F238E27FC236}">
-                <a16:creationId xmlns:a16="http://schemas.microsoft.com/office/drawing/2014/main" id="{0ADC48D5-0243-FA0A-D556-7E65DB8D4EB5}"/>
-              </a:ext>
-            </a:extLst>
-          </p:cNvPr>
-          <p:cNvSpPr>
-            <a:spLocks noGrp="1"/>
-          </p:cNvSpPr>
-          <p:nvPr>
-            <p:ph idx="1"/>
-          </p:nvPr>
-        </p:nvSpPr>
-        <p:spPr/>
-        <p:txBody>
-          <a:bodyPr/>
-          <a:lstStyle/>
-          <a:p>
-            <a:pPr marL="0" indent="0">
-              <a:buNone/>
-            </a:pPr>
-            <a:r>
-              <a:rPr lang="en-US" dirty="0"/>
-              <a:t>Login </a:t>
-            </a:r>
-          </a:p>
-          <a:p>
-            <a:pPr marL="0" indent="0">
-              <a:buNone/>
-            </a:pPr>
-            <a:r>
-              <a:rPr lang="en-US" dirty="0"/>
-              <a:t>information</a:t>
-            </a:r>
-          </a:p>
-          <a:p>
+            </a:br>
             <a:endParaRPr lang="en-US" dirty="0"/>
           </a:p>
-          <a:p>
-            <a:pPr marL="0" indent="0">
-              <a:buNone/>
-            </a:pPr>
+        </p:txBody>
+      </p:sp>
+      <p:sp>
+        <p:nvSpPr>
+          <p:cNvPr id="3" name="Text Placeholder 2">
+            <a:extLst>
+              <a:ext uri="{FF2B5EF4-FFF2-40B4-BE49-F238E27FC236}">
+                <a16:creationId xmlns:a16="http://schemas.microsoft.com/office/drawing/2014/main" id="{3D7FFFA0-16BE-F9B3-328D-D9388E0C3860}"/>
+              </a:ext>
+            </a:extLst>
+          </p:cNvPr>
+          <p:cNvSpPr>
+            <a:spLocks noGrp="1"/>
+          </p:cNvSpPr>
+          <p:nvPr>
+            <p:ph type="body" idx="1"/>
+          </p:nvPr>
+        </p:nvSpPr>
+        <p:spPr/>
+        <p:txBody>
+          <a:bodyPr/>
+          <a:lstStyle/>
+          <a:p>
             <a:endParaRPr lang="en-US" dirty="0"/>
           </a:p>
         </p:txBody>
       </p:sp>
-      <p:pic>
-        <p:nvPicPr>
-          <p:cNvPr id="5" name="Picture 4">
-            <a:extLst>
-              <a:ext uri="{FF2B5EF4-FFF2-40B4-BE49-F238E27FC236}">
-                <a16:creationId xmlns:a16="http://schemas.microsoft.com/office/drawing/2014/main" id="{818481AA-B07A-F927-C584-008FEF9C705B}"/>
-              </a:ext>
-            </a:extLst>
-          </p:cNvPr>
-          <p:cNvPicPr>
-            <a:picLocks noChangeAspect="1"/>
-          </p:cNvPicPr>
+      <p:sp>
+        <p:nvSpPr>
+          <p:cNvPr id="4" name="Rectangle: Rounded Corners 3">
+            <a:hlinkClick r:id="rId2" action="ppaction://hlinksldjump"/>
+            <a:extLst>
+              <a:ext uri="{FF2B5EF4-FFF2-40B4-BE49-F238E27FC236}">
+                <a16:creationId xmlns:a16="http://schemas.microsoft.com/office/drawing/2014/main" id="{F6C7F443-AEAC-8AF7-E8EF-FB57D75AA056}"/>
+              </a:ext>
+            </a:extLst>
+          </p:cNvPr>
+          <p:cNvSpPr/>
           <p:nvPr/>
-        </p:nvPicPr>
-        <p:blipFill>
-          <a:blip r:embed="rId2"/>
-          <a:stretch>
-            <a:fillRect/>
-          </a:stretch>
-        </p:blipFill>
+        </p:nvSpPr>
         <p:spPr>
           <a:xfrm>
-            <a:off x="3838260" y="1825625"/>
-            <a:ext cx="4515480" cy="4848902"/>
+            <a:off x="11226800" y="107950"/>
+            <a:ext cx="812800" cy="317500"/>
           </a:xfrm>
-          <a:prstGeom prst="rect">
+          <a:prstGeom prst="roundRect">
             <a:avLst/>
           </a:prstGeom>
         </p:spPr>
-      </p:pic>
+        <p:style>
+          <a:lnRef idx="1">
+            <a:schemeClr val="accent4"/>
+          </a:lnRef>
+          <a:fillRef idx="2">
+            <a:schemeClr val="accent4"/>
+          </a:fillRef>
+          <a:effectRef idx="1">
+            <a:schemeClr val="accent4"/>
+          </a:effectRef>
+          <a:fontRef idx="minor">
+            <a:schemeClr val="dk1"/>
+          </a:fontRef>
+        </p:style>
+        <p:txBody>
+          <a:bodyPr rtlCol="0" anchor="ctr"/>
+          <a:lstStyle/>
+          <a:p>
+            <a:pPr algn="ctr"/>
+            <a:r>
+              <a:rPr lang="en-US" sz="1200" dirty="0"/>
+              <a:t>HOME</a:t>
+            </a:r>
+          </a:p>
+        </p:txBody>
+      </p:sp>
     </p:spTree>
     <p:extLst>
       <p:ext uri="{BB962C8B-B14F-4D97-AF65-F5344CB8AC3E}">
-        <p14:creationId xmlns:p14="http://schemas.microsoft.com/office/powerpoint/2010/main" val="2535586761"/>
+        <p14:creationId xmlns:p14="http://schemas.microsoft.com/office/powerpoint/2010/main" val="2038589990"/>
       </p:ext>
     </p:extLst>
   </p:cSld>
@@ -6938,6 +7997,371 @@
           <p:cNvPr id="2" name="Title 1">
             <a:extLst>
               <a:ext uri="{FF2B5EF4-FFF2-40B4-BE49-F238E27FC236}">
+                <a16:creationId xmlns:a16="http://schemas.microsoft.com/office/drawing/2014/main" id="{844D4D66-3814-B138-AF30-A282C61B0C51}"/>
+              </a:ext>
+            </a:extLst>
+          </p:cNvPr>
+          <p:cNvSpPr>
+            <a:spLocks noGrp="1"/>
+          </p:cNvSpPr>
+          <p:nvPr>
+            <p:ph type="title"/>
+          </p:nvPr>
+        </p:nvSpPr>
+        <p:spPr/>
+        <p:txBody>
+          <a:bodyPr/>
+          <a:lstStyle/>
+          <a:p>
+            <a:r>
+              <a:rPr lang="en-US" dirty="0"/>
+              <a:t>Connecting to DataWrangling2025 SQL Server through SSMS</a:t>
+            </a:r>
+          </a:p>
+        </p:txBody>
+      </p:sp>
+      <p:sp>
+        <p:nvSpPr>
+          <p:cNvPr id="3" name="Content Placeholder 2">
+            <a:extLst>
+              <a:ext uri="{FF2B5EF4-FFF2-40B4-BE49-F238E27FC236}">
+                <a16:creationId xmlns:a16="http://schemas.microsoft.com/office/drawing/2014/main" id="{451AC857-3F7E-F462-8D54-A1A4E4550545}"/>
+              </a:ext>
+            </a:extLst>
+          </p:cNvPr>
+          <p:cNvSpPr>
+            <a:spLocks noGrp="1"/>
+          </p:cNvSpPr>
+          <p:nvPr>
+            <p:ph idx="1"/>
+          </p:nvPr>
+        </p:nvSpPr>
+        <p:spPr/>
+        <p:txBody>
+          <a:bodyPr/>
+          <a:lstStyle/>
+          <a:p>
+            <a:r>
+              <a:rPr lang="en-US" dirty="0"/>
+              <a:t>Install SSMS (</a:t>
+            </a:r>
+            <a:r>
+              <a:rPr lang="en-US" dirty="0">
+                <a:hlinkClick r:id="rId2"/>
+              </a:rPr>
+              <a:t>https://learn.microsoft.com/en-us/ssms/install/install</a:t>
+            </a:r>
+            <a:r>
+              <a:rPr lang="en-US" dirty="0"/>
+              <a:t>)</a:t>
+            </a:r>
+          </a:p>
+          <a:p>
+            <a:pPr marL="0" indent="0">
+              <a:buNone/>
+            </a:pPr>
+            <a:endParaRPr lang="en-US" dirty="0"/>
+          </a:p>
+        </p:txBody>
+      </p:sp>
+      <p:pic>
+        <p:nvPicPr>
+          <p:cNvPr id="5" name="Picture 4">
+            <a:extLst>
+              <a:ext uri="{FF2B5EF4-FFF2-40B4-BE49-F238E27FC236}">
+                <a16:creationId xmlns:a16="http://schemas.microsoft.com/office/drawing/2014/main" id="{7238E87F-990D-D5A1-9573-6B5FEA69EBF1}"/>
+              </a:ext>
+            </a:extLst>
+          </p:cNvPr>
+          <p:cNvPicPr>
+            <a:picLocks noChangeAspect="1"/>
+          </p:cNvPicPr>
+          <p:nvPr/>
+        </p:nvPicPr>
+        <p:blipFill>
+          <a:blip r:embed="rId3"/>
+          <a:stretch>
+            <a:fillRect/>
+          </a:stretch>
+        </p:blipFill>
+        <p:spPr>
+          <a:xfrm>
+            <a:off x="2801565" y="2907206"/>
+            <a:ext cx="4997015" cy="3325242"/>
+          </a:xfrm>
+          <a:prstGeom prst="rect">
+            <a:avLst/>
+          </a:prstGeom>
+        </p:spPr>
+      </p:pic>
+      <p:sp>
+        <p:nvSpPr>
+          <p:cNvPr id="8" name="Rectangle: Rounded Corners 7">
+            <a:hlinkClick r:id="rId4" action="ppaction://hlinksldjump"/>
+            <a:extLst>
+              <a:ext uri="{FF2B5EF4-FFF2-40B4-BE49-F238E27FC236}">
+                <a16:creationId xmlns:a16="http://schemas.microsoft.com/office/drawing/2014/main" id="{6EB22305-DCDD-3E18-6940-2E84866371F1}"/>
+              </a:ext>
+            </a:extLst>
+          </p:cNvPr>
+          <p:cNvSpPr/>
+          <p:nvPr/>
+        </p:nvSpPr>
+        <p:spPr>
+          <a:xfrm>
+            <a:off x="11226800" y="107950"/>
+            <a:ext cx="812800" cy="317500"/>
+          </a:xfrm>
+          <a:prstGeom prst="roundRect">
+            <a:avLst/>
+          </a:prstGeom>
+        </p:spPr>
+        <p:style>
+          <a:lnRef idx="1">
+            <a:schemeClr val="accent4"/>
+          </a:lnRef>
+          <a:fillRef idx="2">
+            <a:schemeClr val="accent4"/>
+          </a:fillRef>
+          <a:effectRef idx="1">
+            <a:schemeClr val="accent4"/>
+          </a:effectRef>
+          <a:fontRef idx="minor">
+            <a:schemeClr val="dk1"/>
+          </a:fontRef>
+        </p:style>
+        <p:txBody>
+          <a:bodyPr rtlCol="0" anchor="ctr"/>
+          <a:lstStyle/>
+          <a:p>
+            <a:pPr algn="ctr"/>
+            <a:r>
+              <a:rPr lang="en-US" sz="1200" dirty="0"/>
+              <a:t>HOME</a:t>
+            </a:r>
+          </a:p>
+        </p:txBody>
+      </p:sp>
+    </p:spTree>
+    <p:extLst>
+      <p:ext uri="{BB962C8B-B14F-4D97-AF65-F5344CB8AC3E}">
+        <p14:creationId xmlns:p14="http://schemas.microsoft.com/office/powerpoint/2010/main" val="3333290551"/>
+      </p:ext>
+    </p:extLst>
+  </p:cSld>
+  <p:clrMapOvr>
+    <a:masterClrMapping/>
+  </p:clrMapOvr>
+</p:sld>
+</file>
+
+<file path=ppt/slides/slide6.xml><?xml version="1.0" encoding="utf-8"?>
+<p:sld xmlns:a="http://schemas.openxmlformats.org/drawingml/2006/main" xmlns:r="http://schemas.openxmlformats.org/officeDocument/2006/relationships" xmlns:p="http://schemas.openxmlformats.org/presentationml/2006/main">
+  <p:cSld>
+    <p:spTree>
+      <p:nvGrpSpPr>
+        <p:cNvPr id="1" name=""/>
+        <p:cNvGrpSpPr/>
+        <p:nvPr/>
+      </p:nvGrpSpPr>
+      <p:grpSpPr>
+        <a:xfrm>
+          <a:off x="0" y="0"/>
+          <a:ext cx="0" cy="0"/>
+          <a:chOff x="0" y="0"/>
+          <a:chExt cx="0" cy="0"/>
+        </a:xfrm>
+      </p:grpSpPr>
+      <p:sp>
+        <p:nvSpPr>
+          <p:cNvPr id="2" name="Title 1">
+            <a:extLst>
+              <a:ext uri="{FF2B5EF4-FFF2-40B4-BE49-F238E27FC236}">
+                <a16:creationId xmlns:a16="http://schemas.microsoft.com/office/drawing/2014/main" id="{BCF1CA1B-51A7-BEDF-9A15-299B5A07E8D2}"/>
+              </a:ext>
+            </a:extLst>
+          </p:cNvPr>
+          <p:cNvSpPr>
+            <a:spLocks noGrp="1"/>
+          </p:cNvSpPr>
+          <p:nvPr>
+            <p:ph type="title"/>
+          </p:nvPr>
+        </p:nvSpPr>
+        <p:spPr/>
+        <p:txBody>
+          <a:bodyPr/>
+          <a:lstStyle/>
+          <a:p>
+            <a:r>
+              <a:rPr lang="en-US" dirty="0"/>
+              <a:t>Connecting to DataWrangling2025 SQL Server through SSMS (cont.)</a:t>
+            </a:r>
+          </a:p>
+        </p:txBody>
+      </p:sp>
+      <p:sp>
+        <p:nvSpPr>
+          <p:cNvPr id="3" name="Content Placeholder 2">
+            <a:extLst>
+              <a:ext uri="{FF2B5EF4-FFF2-40B4-BE49-F238E27FC236}">
+                <a16:creationId xmlns:a16="http://schemas.microsoft.com/office/drawing/2014/main" id="{0ADC48D5-0243-FA0A-D556-7E65DB8D4EB5}"/>
+              </a:ext>
+            </a:extLst>
+          </p:cNvPr>
+          <p:cNvSpPr>
+            <a:spLocks noGrp="1"/>
+          </p:cNvSpPr>
+          <p:nvPr>
+            <p:ph idx="1"/>
+          </p:nvPr>
+        </p:nvSpPr>
+        <p:spPr/>
+        <p:txBody>
+          <a:bodyPr/>
+          <a:lstStyle/>
+          <a:p>
+            <a:pPr marL="0" indent="0">
+              <a:buNone/>
+            </a:pPr>
+            <a:r>
+              <a:rPr lang="en-US" dirty="0"/>
+              <a:t>Login </a:t>
+            </a:r>
+          </a:p>
+          <a:p>
+            <a:pPr marL="0" indent="0">
+              <a:buNone/>
+            </a:pPr>
+            <a:r>
+              <a:rPr lang="en-US" dirty="0"/>
+              <a:t>information</a:t>
+            </a:r>
+          </a:p>
+          <a:p>
+            <a:endParaRPr lang="en-US" dirty="0"/>
+          </a:p>
+          <a:p>
+            <a:pPr marL="0" indent="0">
+              <a:buNone/>
+            </a:pPr>
+            <a:endParaRPr lang="en-US" dirty="0"/>
+          </a:p>
+        </p:txBody>
+      </p:sp>
+      <p:pic>
+        <p:nvPicPr>
+          <p:cNvPr id="5" name="Picture 4">
+            <a:extLst>
+              <a:ext uri="{FF2B5EF4-FFF2-40B4-BE49-F238E27FC236}">
+                <a16:creationId xmlns:a16="http://schemas.microsoft.com/office/drawing/2014/main" id="{818481AA-B07A-F927-C584-008FEF9C705B}"/>
+              </a:ext>
+            </a:extLst>
+          </p:cNvPr>
+          <p:cNvPicPr>
+            <a:picLocks noChangeAspect="1"/>
+          </p:cNvPicPr>
+          <p:nvPr/>
+        </p:nvPicPr>
+        <p:blipFill>
+          <a:blip r:embed="rId2"/>
+          <a:stretch>
+            <a:fillRect/>
+          </a:stretch>
+        </p:blipFill>
+        <p:spPr>
+          <a:xfrm>
+            <a:off x="3838260" y="1825625"/>
+            <a:ext cx="4515480" cy="4848902"/>
+          </a:xfrm>
+          <a:prstGeom prst="rect">
+            <a:avLst/>
+          </a:prstGeom>
+        </p:spPr>
+      </p:pic>
+      <p:sp>
+        <p:nvSpPr>
+          <p:cNvPr id="8" name="Rectangle: Rounded Corners 7">
+            <a:hlinkClick r:id="rId3" action="ppaction://hlinksldjump"/>
+            <a:extLst>
+              <a:ext uri="{FF2B5EF4-FFF2-40B4-BE49-F238E27FC236}">
+                <a16:creationId xmlns:a16="http://schemas.microsoft.com/office/drawing/2014/main" id="{E16CC9A1-CCCC-593D-D1DA-ABB09271C59A}"/>
+              </a:ext>
+            </a:extLst>
+          </p:cNvPr>
+          <p:cNvSpPr/>
+          <p:nvPr/>
+        </p:nvSpPr>
+        <p:spPr>
+          <a:xfrm>
+            <a:off x="11226800" y="107950"/>
+            <a:ext cx="812800" cy="317500"/>
+          </a:xfrm>
+          <a:prstGeom prst="roundRect">
+            <a:avLst/>
+          </a:prstGeom>
+        </p:spPr>
+        <p:style>
+          <a:lnRef idx="1">
+            <a:schemeClr val="accent4"/>
+          </a:lnRef>
+          <a:fillRef idx="2">
+            <a:schemeClr val="accent4"/>
+          </a:fillRef>
+          <a:effectRef idx="1">
+            <a:schemeClr val="accent4"/>
+          </a:effectRef>
+          <a:fontRef idx="minor">
+            <a:schemeClr val="dk1"/>
+          </a:fontRef>
+        </p:style>
+        <p:txBody>
+          <a:bodyPr rtlCol="0" anchor="ctr"/>
+          <a:lstStyle/>
+          <a:p>
+            <a:pPr algn="ctr"/>
+            <a:r>
+              <a:rPr lang="en-US" sz="1200" dirty="0"/>
+              <a:t>HOME</a:t>
+            </a:r>
+          </a:p>
+        </p:txBody>
+      </p:sp>
+    </p:spTree>
+    <p:extLst>
+      <p:ext uri="{BB962C8B-B14F-4D97-AF65-F5344CB8AC3E}">
+        <p14:creationId xmlns:p14="http://schemas.microsoft.com/office/powerpoint/2010/main" val="2535586761"/>
+      </p:ext>
+    </p:extLst>
+  </p:cSld>
+  <p:clrMapOvr>
+    <a:masterClrMapping/>
+  </p:clrMapOvr>
+</p:sld>
+</file>
+
+<file path=ppt/slides/slide7.xml><?xml version="1.0" encoding="utf-8"?>
+<p:sld xmlns:a="http://schemas.openxmlformats.org/drawingml/2006/main" xmlns:r="http://schemas.openxmlformats.org/officeDocument/2006/relationships" xmlns:p="http://schemas.openxmlformats.org/presentationml/2006/main">
+  <p:cSld>
+    <p:spTree>
+      <p:nvGrpSpPr>
+        <p:cNvPr id="1" name=""/>
+        <p:cNvGrpSpPr/>
+        <p:nvPr/>
+      </p:nvGrpSpPr>
+      <p:grpSpPr>
+        <a:xfrm>
+          <a:off x="0" y="0"/>
+          <a:ext cx="0" cy="0"/>
+          <a:chOff x="0" y="0"/>
+          <a:chExt cx="0" cy="0"/>
+        </a:xfrm>
+      </p:grpSpPr>
+      <p:sp>
+        <p:nvSpPr>
+          <p:cNvPr id="2" name="Title 1">
+            <a:extLst>
+              <a:ext uri="{FF2B5EF4-FFF2-40B4-BE49-F238E27FC236}">
                 <a16:creationId xmlns:a16="http://schemas.microsoft.com/office/drawing/2014/main" id="{AFA33274-E031-4E7A-7DF1-5255062C0CEE}"/>
               </a:ext>
             </a:extLst>
@@ -7025,374 +8449,58 @@
           </a:prstGeom>
         </p:spPr>
       </p:pic>
+      <p:sp>
+        <p:nvSpPr>
+          <p:cNvPr id="8" name="Rectangle: Rounded Corners 7">
+            <a:hlinkClick r:id="rId3" action="ppaction://hlinksldjump"/>
+            <a:extLst>
+              <a:ext uri="{FF2B5EF4-FFF2-40B4-BE49-F238E27FC236}">
+                <a16:creationId xmlns:a16="http://schemas.microsoft.com/office/drawing/2014/main" id="{88FD9BC0-B50D-2BC5-50FB-76DC67925C71}"/>
+              </a:ext>
+            </a:extLst>
+          </p:cNvPr>
+          <p:cNvSpPr/>
+          <p:nvPr/>
+        </p:nvSpPr>
+        <p:spPr>
+          <a:xfrm>
+            <a:off x="11226800" y="107950"/>
+            <a:ext cx="812800" cy="317500"/>
+          </a:xfrm>
+          <a:prstGeom prst="roundRect">
+            <a:avLst/>
+          </a:prstGeom>
+        </p:spPr>
+        <p:style>
+          <a:lnRef idx="1">
+            <a:schemeClr val="accent4"/>
+          </a:lnRef>
+          <a:fillRef idx="2">
+            <a:schemeClr val="accent4"/>
+          </a:fillRef>
+          <a:effectRef idx="1">
+            <a:schemeClr val="accent4"/>
+          </a:effectRef>
+          <a:fontRef idx="minor">
+            <a:schemeClr val="dk1"/>
+          </a:fontRef>
+        </p:style>
+        <p:txBody>
+          <a:bodyPr rtlCol="0" anchor="ctr"/>
+          <a:lstStyle/>
+          <a:p>
+            <a:pPr algn="ctr"/>
+            <a:r>
+              <a:rPr lang="en-US" sz="1200" dirty="0"/>
+              <a:t>HOME</a:t>
+            </a:r>
+          </a:p>
+        </p:txBody>
+      </p:sp>
     </p:spTree>
     <p:extLst>
       <p:ext uri="{BB962C8B-B14F-4D97-AF65-F5344CB8AC3E}">
         <p14:creationId xmlns:p14="http://schemas.microsoft.com/office/powerpoint/2010/main" val="1009418026"/>
-      </p:ext>
-    </p:extLst>
-  </p:cSld>
-  <p:clrMapOvr>
-    <a:masterClrMapping/>
-  </p:clrMapOvr>
-</p:sld>
-</file>
-
-<file path=ppt/slides/slide6.xml><?xml version="1.0" encoding="utf-8"?>
-<p:sld xmlns:a="http://schemas.openxmlformats.org/drawingml/2006/main" xmlns:r="http://schemas.openxmlformats.org/officeDocument/2006/relationships" xmlns:p="http://schemas.openxmlformats.org/presentationml/2006/main">
-  <p:cSld>
-    <p:spTree>
-      <p:nvGrpSpPr>
-        <p:cNvPr id="1" name="">
-          <a:extLst>
-            <a:ext uri="{FF2B5EF4-FFF2-40B4-BE49-F238E27FC236}">
-              <a16:creationId xmlns:a16="http://schemas.microsoft.com/office/drawing/2014/main" id="{F9825BB3-5B63-C64A-69B1-AA89CD122CAF}"/>
-            </a:ext>
-          </a:extLst>
-        </p:cNvPr>
-        <p:cNvGrpSpPr/>
-        <p:nvPr/>
-      </p:nvGrpSpPr>
-      <p:grpSpPr>
-        <a:xfrm>
-          <a:off x="0" y="0"/>
-          <a:ext cx="0" cy="0"/>
-          <a:chOff x="0" y="0"/>
-          <a:chExt cx="0" cy="0"/>
-        </a:xfrm>
-      </p:grpSpPr>
-      <p:sp>
-        <p:nvSpPr>
-          <p:cNvPr id="2" name="Title 1">
-            <a:extLst>
-              <a:ext uri="{FF2B5EF4-FFF2-40B4-BE49-F238E27FC236}">
-                <a16:creationId xmlns:a16="http://schemas.microsoft.com/office/drawing/2014/main" id="{ABE7FD9A-8C31-A640-A046-9686547AA35F}"/>
-              </a:ext>
-            </a:extLst>
-          </p:cNvPr>
-          <p:cNvSpPr>
-            <a:spLocks noGrp="1"/>
-          </p:cNvSpPr>
-          <p:nvPr>
-            <p:ph type="title"/>
-          </p:nvPr>
-        </p:nvSpPr>
-        <p:spPr/>
-        <p:txBody>
-          <a:bodyPr/>
-          <a:lstStyle/>
-          <a:p>
-            <a:r>
-              <a:rPr lang="en-US" dirty="0"/>
-              <a:t>Repository </a:t>
-            </a:r>
-            <a:r>
-              <a:rPr lang="en-US" dirty="0" err="1"/>
-              <a:t>DataWrangling_R</a:t>
-            </a:r>
-            <a:r>
-              <a:rPr lang="en-US" dirty="0"/>
-              <a:t> in St. Jude MS ABDS, </a:t>
-            </a:r>
-            <a:r>
-              <a:rPr lang="en-US" dirty="0" err="1"/>
-              <a:t>Github</a:t>
-            </a:r>
-            <a:endParaRPr lang="en-US" dirty="0"/>
-          </a:p>
-        </p:txBody>
-      </p:sp>
-      <p:sp>
-        <p:nvSpPr>
-          <p:cNvPr id="3" name="Content Placeholder 2">
-            <a:extLst>
-              <a:ext uri="{FF2B5EF4-FFF2-40B4-BE49-F238E27FC236}">
-                <a16:creationId xmlns:a16="http://schemas.microsoft.com/office/drawing/2014/main" id="{04714D8C-A90A-BB15-0714-11EA73B71B4C}"/>
-              </a:ext>
-            </a:extLst>
-          </p:cNvPr>
-          <p:cNvSpPr>
-            <a:spLocks noGrp="1"/>
-          </p:cNvSpPr>
-          <p:nvPr>
-            <p:ph idx="1"/>
-          </p:nvPr>
-        </p:nvSpPr>
-        <p:spPr/>
-        <p:txBody>
-          <a:bodyPr/>
-          <a:lstStyle/>
-          <a:p>
-            <a:r>
-              <a:rPr lang="en-US" dirty="0"/>
-              <a:t>Repository </a:t>
-            </a:r>
-            <a:r>
-              <a:rPr lang="en-US" dirty="0" err="1"/>
-              <a:t>DataWrangling_R</a:t>
-            </a:r>
-            <a:r>
-              <a:rPr lang="en-US" dirty="0"/>
-              <a:t> in St. Jude MS ABDS, </a:t>
-            </a:r>
-            <a:r>
-              <a:rPr lang="en-US" dirty="0" err="1"/>
-              <a:t>Github</a:t>
-            </a:r>
-            <a:endParaRPr lang="en-US" dirty="0"/>
-          </a:p>
-          <a:p>
-            <a:r>
-              <a:rPr lang="en-US" dirty="0"/>
-              <a:t>Branch testing</a:t>
-            </a:r>
-          </a:p>
-          <a:p>
-            <a:endParaRPr lang="en-US" dirty="0"/>
-          </a:p>
-        </p:txBody>
-      </p:sp>
-      <p:pic>
-        <p:nvPicPr>
-          <p:cNvPr id="7" name="Picture 6">
-            <a:extLst>
-              <a:ext uri="{FF2B5EF4-FFF2-40B4-BE49-F238E27FC236}">
-                <a16:creationId xmlns:a16="http://schemas.microsoft.com/office/drawing/2014/main" id="{8E5211B2-9C1E-EECA-86ED-16F504FAD7EF}"/>
-              </a:ext>
-            </a:extLst>
-          </p:cNvPr>
-          <p:cNvPicPr>
-            <a:picLocks noChangeAspect="1"/>
-          </p:cNvPicPr>
-          <p:nvPr/>
-        </p:nvPicPr>
-        <p:blipFill>
-          <a:blip r:embed="rId2"/>
-          <a:stretch>
-            <a:fillRect/>
-          </a:stretch>
-        </p:blipFill>
-        <p:spPr>
-          <a:xfrm>
-            <a:off x="6096000" y="2490662"/>
-            <a:ext cx="5585085" cy="2444166"/>
-          </a:xfrm>
-          <a:prstGeom prst="rect">
-            <a:avLst/>
-          </a:prstGeom>
-        </p:spPr>
-      </p:pic>
-      <p:pic>
-        <p:nvPicPr>
-          <p:cNvPr id="5" name="Picture 4">
-            <a:extLst>
-              <a:ext uri="{FF2B5EF4-FFF2-40B4-BE49-F238E27FC236}">
-                <a16:creationId xmlns:a16="http://schemas.microsoft.com/office/drawing/2014/main" id="{739F46F4-D073-1294-B460-E3495BC1B0A4}"/>
-              </a:ext>
-            </a:extLst>
-          </p:cNvPr>
-          <p:cNvPicPr>
-            <a:picLocks noChangeAspect="1"/>
-          </p:cNvPicPr>
-          <p:nvPr/>
-        </p:nvPicPr>
-        <p:blipFill>
-          <a:blip r:embed="rId3"/>
-          <a:stretch>
-            <a:fillRect/>
-          </a:stretch>
-        </p:blipFill>
-        <p:spPr>
-          <a:xfrm>
-            <a:off x="1776920" y="3376782"/>
-            <a:ext cx="5800203" cy="3116093"/>
-          </a:xfrm>
-          <a:prstGeom prst="rect">
-            <a:avLst/>
-          </a:prstGeom>
-        </p:spPr>
-      </p:pic>
-    </p:spTree>
-    <p:extLst>
-      <p:ext uri="{BB962C8B-B14F-4D97-AF65-F5344CB8AC3E}">
-        <p14:creationId xmlns:p14="http://schemas.microsoft.com/office/powerpoint/2010/main" val="2839645707"/>
-      </p:ext>
-    </p:extLst>
-  </p:cSld>
-  <p:clrMapOvr>
-    <a:masterClrMapping/>
-  </p:clrMapOvr>
-</p:sld>
-</file>
-
-<file path=ppt/slides/slide7.xml><?xml version="1.0" encoding="utf-8"?>
-<p:sld xmlns:a="http://schemas.openxmlformats.org/drawingml/2006/main" xmlns:r="http://schemas.openxmlformats.org/officeDocument/2006/relationships" xmlns:p="http://schemas.openxmlformats.org/presentationml/2006/main">
-  <p:cSld>
-    <p:spTree>
-      <p:nvGrpSpPr>
-        <p:cNvPr id="1" name="">
-          <a:extLst>
-            <a:ext uri="{FF2B5EF4-FFF2-40B4-BE49-F238E27FC236}">
-              <a16:creationId xmlns:a16="http://schemas.microsoft.com/office/drawing/2014/main" id="{AE615FE5-E8BE-3F95-1F43-3E193F4F93EC}"/>
-            </a:ext>
-          </a:extLst>
-        </p:cNvPr>
-        <p:cNvGrpSpPr/>
-        <p:nvPr/>
-      </p:nvGrpSpPr>
-      <p:grpSpPr>
-        <a:xfrm>
-          <a:off x="0" y="0"/>
-          <a:ext cx="0" cy="0"/>
-          <a:chOff x="0" y="0"/>
-          <a:chExt cx="0" cy="0"/>
-        </a:xfrm>
-      </p:grpSpPr>
-      <p:sp>
-        <p:nvSpPr>
-          <p:cNvPr id="2" name="Title 1">
-            <a:extLst>
-              <a:ext uri="{FF2B5EF4-FFF2-40B4-BE49-F238E27FC236}">
-                <a16:creationId xmlns:a16="http://schemas.microsoft.com/office/drawing/2014/main" id="{76713FEC-397D-FD4B-A53F-455B271D0633}"/>
-              </a:ext>
-            </a:extLst>
-          </p:cNvPr>
-          <p:cNvSpPr>
-            <a:spLocks noGrp="1"/>
-          </p:cNvSpPr>
-          <p:nvPr>
-            <p:ph type="title"/>
-          </p:nvPr>
-        </p:nvSpPr>
-        <p:spPr/>
-        <p:txBody>
-          <a:bodyPr/>
-          <a:lstStyle/>
-          <a:p>
-            <a:r>
-              <a:rPr lang="en-US" dirty="0"/>
-              <a:t>Connecting to DataWrangling2025 SQL Server through SAS Server</a:t>
-            </a:r>
-          </a:p>
-        </p:txBody>
-      </p:sp>
-      <p:sp>
-        <p:nvSpPr>
-          <p:cNvPr id="3" name="Content Placeholder 2">
-            <a:extLst>
-              <a:ext uri="{FF2B5EF4-FFF2-40B4-BE49-F238E27FC236}">
-                <a16:creationId xmlns:a16="http://schemas.microsoft.com/office/drawing/2014/main" id="{BCB98F0A-3DA1-1B34-0266-D74AE1C09A2E}"/>
-              </a:ext>
-            </a:extLst>
-          </p:cNvPr>
-          <p:cNvSpPr>
-            <a:spLocks noGrp="1"/>
-          </p:cNvSpPr>
-          <p:nvPr>
-            <p:ph idx="1"/>
-          </p:nvPr>
-        </p:nvSpPr>
-        <p:spPr>
-          <a:xfrm>
-            <a:off x="838200" y="1825625"/>
-            <a:ext cx="5458838" cy="4351338"/>
-          </a:xfrm>
-        </p:spPr>
-        <p:txBody>
-          <a:bodyPr>
-            <a:normAutofit/>
-          </a:bodyPr>
-          <a:lstStyle/>
-          <a:p>
-            <a:pPr marL="0" indent="0">
-              <a:buNone/>
-            </a:pPr>
-            <a:r>
-              <a:rPr lang="en-US" b="1" dirty="0"/>
-              <a:t>Using data source name (DSN)</a:t>
-            </a:r>
-          </a:p>
-          <a:p>
-            <a:r>
-              <a:rPr lang="en-US" dirty="0"/>
-              <a:t>Run </a:t>
-            </a:r>
-            <a:r>
-              <a:rPr lang="en-US" dirty="0" err="1"/>
-              <a:t>test_sql.sas</a:t>
-            </a:r>
-            <a:r>
-              <a:rPr lang="en-US" dirty="0"/>
-              <a:t> (lines 13-15) in SAS Studio</a:t>
-            </a:r>
-          </a:p>
-          <a:p>
-            <a:r>
-              <a:rPr lang="en-US" dirty="0"/>
-              <a:t>See next slide for the expected output</a:t>
-            </a:r>
-          </a:p>
-          <a:p>
-            <a:r>
-              <a:rPr lang="en-US" dirty="0"/>
-              <a:t>If you do not see the expected outputs, email </a:t>
-            </a:r>
-            <a:r>
-              <a:rPr lang="en-US" dirty="0">
-                <a:hlinkClick r:id="rId3"/>
-              </a:rPr>
-              <a:t>Yichen.chen@stjude.org</a:t>
-            </a:r>
-            <a:r>
-              <a:rPr lang="en-US" dirty="0"/>
-              <a:t> with screenshot</a:t>
-            </a:r>
-          </a:p>
-          <a:p>
-            <a:endParaRPr lang="en-US" dirty="0"/>
-          </a:p>
-          <a:p>
-            <a:pPr marL="0" indent="0">
-              <a:buNone/>
-            </a:pPr>
-            <a:endParaRPr lang="en-US" dirty="0"/>
-          </a:p>
-        </p:txBody>
-      </p:sp>
-      <p:pic>
-        <p:nvPicPr>
-          <p:cNvPr id="5" name="Picture 4">
-            <a:extLst>
-              <a:ext uri="{FF2B5EF4-FFF2-40B4-BE49-F238E27FC236}">
-                <a16:creationId xmlns:a16="http://schemas.microsoft.com/office/drawing/2014/main" id="{CCD5DB46-F544-B1CE-950D-6021F3FA5F72}"/>
-              </a:ext>
-            </a:extLst>
-          </p:cNvPr>
-          <p:cNvPicPr>
-            <a:picLocks noChangeAspect="1"/>
-          </p:cNvPicPr>
-          <p:nvPr/>
-        </p:nvPicPr>
-        <p:blipFill>
-          <a:blip r:embed="rId4"/>
-          <a:stretch>
-            <a:fillRect/>
-          </a:stretch>
-        </p:blipFill>
-        <p:spPr>
-          <a:xfrm>
-            <a:off x="6297038" y="3053181"/>
-            <a:ext cx="5792008" cy="1257475"/>
-          </a:xfrm>
-          <a:prstGeom prst="rect">
-            <a:avLst/>
-          </a:prstGeom>
-        </p:spPr>
-      </p:pic>
-    </p:spTree>
-    <p:extLst>
-      <p:ext uri="{BB962C8B-B14F-4D97-AF65-F5344CB8AC3E}">
-        <p14:creationId xmlns:p14="http://schemas.microsoft.com/office/powerpoint/2010/main" val="2824653451"/>
       </p:ext>
     </p:extLst>
   </p:cSld>
@@ -7424,7 +8532,7 @@
           <p:cNvPr id="2" name="Title 1">
             <a:extLst>
               <a:ext uri="{FF2B5EF4-FFF2-40B4-BE49-F238E27FC236}">
-                <a16:creationId xmlns:a16="http://schemas.microsoft.com/office/drawing/2014/main" id="{2E026C02-9456-53C2-4AAD-3B57C20C3C65}"/>
+                <a16:creationId xmlns:a16="http://schemas.microsoft.com/office/drawing/2014/main" id="{F0F6E056-DA5D-2D7C-5337-040E11F03A53}"/>
               </a:ext>
             </a:extLst>
           </p:cNvPr>
@@ -7442,109 +8550,88 @@
           <a:p>
             <a:r>
               <a:rPr lang="en-US" dirty="0"/>
-              <a:t>Connecting to DataWrangling2025 SQL Server through SAS Server (cont.)</a:t>
-            </a:r>
-          </a:p>
-        </p:txBody>
-      </p:sp>
-      <p:sp>
-        <p:nvSpPr>
-          <p:cNvPr id="3" name="Content Placeholder 2">
-            <a:extLst>
-              <a:ext uri="{FF2B5EF4-FFF2-40B4-BE49-F238E27FC236}">
-                <a16:creationId xmlns:a16="http://schemas.microsoft.com/office/drawing/2014/main" id="{07450B49-6BF5-5612-32D5-91EC0AB85680}"/>
-              </a:ext>
-            </a:extLst>
-          </p:cNvPr>
-          <p:cNvSpPr>
-            <a:spLocks noGrp="1"/>
-          </p:cNvSpPr>
-          <p:nvPr>
-            <p:ph idx="1"/>
-          </p:nvPr>
-        </p:nvSpPr>
-        <p:spPr/>
-        <p:txBody>
-          <a:bodyPr/>
-          <a:lstStyle/>
-          <a:p>
-            <a:r>
-              <a:rPr lang="en-US" dirty="0"/>
-              <a:t>Expected output from method 1 - DSN</a:t>
-            </a:r>
-          </a:p>
-          <a:p>
-            <a:endParaRPr lang="en-US" dirty="0"/>
-          </a:p>
-          <a:p>
-            <a:endParaRPr lang="en-US" dirty="0"/>
-          </a:p>
-        </p:txBody>
-      </p:sp>
-      <p:pic>
-        <p:nvPicPr>
-          <p:cNvPr id="5" name="Picture 4">
-            <a:extLst>
-              <a:ext uri="{FF2B5EF4-FFF2-40B4-BE49-F238E27FC236}">
-                <a16:creationId xmlns:a16="http://schemas.microsoft.com/office/drawing/2014/main" id="{2B12CF7A-1E0F-4B49-7473-4910704DA75C}"/>
-              </a:ext>
-            </a:extLst>
-          </p:cNvPr>
-          <p:cNvPicPr>
-            <a:picLocks noChangeAspect="1"/>
-          </p:cNvPicPr>
+              <a:t>SAS Server</a:t>
+            </a:r>
+          </a:p>
+        </p:txBody>
+      </p:sp>
+      <p:sp>
+        <p:nvSpPr>
+          <p:cNvPr id="3" name="Text Placeholder 2">
+            <a:extLst>
+              <a:ext uri="{FF2B5EF4-FFF2-40B4-BE49-F238E27FC236}">
+                <a16:creationId xmlns:a16="http://schemas.microsoft.com/office/drawing/2014/main" id="{19DF54C0-0CCC-946D-9333-C6DC251AD37B}"/>
+              </a:ext>
+            </a:extLst>
+          </p:cNvPr>
+          <p:cNvSpPr>
+            <a:spLocks noGrp="1"/>
+          </p:cNvSpPr>
+          <p:nvPr>
+            <p:ph type="body" idx="1"/>
+          </p:nvPr>
+        </p:nvSpPr>
+        <p:spPr/>
+        <p:txBody>
+          <a:bodyPr/>
+          <a:lstStyle/>
+          <a:p>
+            <a:endParaRPr lang="en-US"/>
+          </a:p>
+        </p:txBody>
+      </p:sp>
+      <p:sp>
+        <p:nvSpPr>
+          <p:cNvPr id="5" name="Rectangle: Rounded Corners 4">
+            <a:hlinkClick r:id="rId2" action="ppaction://hlinksldjump"/>
+            <a:extLst>
+              <a:ext uri="{FF2B5EF4-FFF2-40B4-BE49-F238E27FC236}">
+                <a16:creationId xmlns:a16="http://schemas.microsoft.com/office/drawing/2014/main" id="{471D5E71-F80C-F8D1-3F12-F3CFD74941B4}"/>
+              </a:ext>
+            </a:extLst>
+          </p:cNvPr>
+          <p:cNvSpPr/>
           <p:nvPr/>
-        </p:nvPicPr>
-        <p:blipFill>
-          <a:blip r:embed="rId2"/>
-          <a:stretch>
-            <a:fillRect/>
-          </a:stretch>
-        </p:blipFill>
+        </p:nvSpPr>
         <p:spPr>
           <a:xfrm>
-            <a:off x="641605" y="2683594"/>
-            <a:ext cx="5095580" cy="3445095"/>
+            <a:off x="11226800" y="107950"/>
+            <a:ext cx="812800" cy="317500"/>
           </a:xfrm>
-          <a:prstGeom prst="rect">
+          <a:prstGeom prst="roundRect">
             <a:avLst/>
           </a:prstGeom>
         </p:spPr>
-      </p:pic>
-      <p:pic>
-        <p:nvPicPr>
-          <p:cNvPr id="8" name="Picture 7">
-            <a:extLst>
-              <a:ext uri="{FF2B5EF4-FFF2-40B4-BE49-F238E27FC236}">
-                <a16:creationId xmlns:a16="http://schemas.microsoft.com/office/drawing/2014/main" id="{32F490B2-5805-E843-A846-B6F2B89465EE}"/>
-              </a:ext>
-            </a:extLst>
-          </p:cNvPr>
-          <p:cNvPicPr>
-            <a:picLocks noChangeAspect="1"/>
-          </p:cNvPicPr>
-          <p:nvPr/>
-        </p:nvPicPr>
-        <p:blipFill>
-          <a:blip r:embed="rId3"/>
-          <a:stretch>
-            <a:fillRect/>
-          </a:stretch>
-        </p:blipFill>
-        <p:spPr>
-          <a:xfrm>
-            <a:off x="6251641" y="2683595"/>
-            <a:ext cx="5616615" cy="3429000"/>
-          </a:xfrm>
-          <a:prstGeom prst="rect">
-            <a:avLst/>
-          </a:prstGeom>
-        </p:spPr>
-      </p:pic>
+        <p:style>
+          <a:lnRef idx="1">
+            <a:schemeClr val="accent4"/>
+          </a:lnRef>
+          <a:fillRef idx="2">
+            <a:schemeClr val="accent4"/>
+          </a:fillRef>
+          <a:effectRef idx="1">
+            <a:schemeClr val="accent4"/>
+          </a:effectRef>
+          <a:fontRef idx="minor">
+            <a:schemeClr val="dk1"/>
+          </a:fontRef>
+        </p:style>
+        <p:txBody>
+          <a:bodyPr rtlCol="0" anchor="ctr"/>
+          <a:lstStyle/>
+          <a:p>
+            <a:pPr algn="ctr"/>
+            <a:r>
+              <a:rPr lang="en-US" sz="1200" dirty="0"/>
+              <a:t>HOME</a:t>
+            </a:r>
+          </a:p>
+        </p:txBody>
+      </p:sp>
     </p:spTree>
     <p:extLst>
       <p:ext uri="{BB962C8B-B14F-4D97-AF65-F5344CB8AC3E}">
-        <p14:creationId xmlns:p14="http://schemas.microsoft.com/office/powerpoint/2010/main" val="2252906759"/>
+        <p14:creationId xmlns:p14="http://schemas.microsoft.com/office/powerpoint/2010/main" val="142539913"/>
       </p:ext>
     </p:extLst>
   </p:cSld>
@@ -7562,7 +8649,7 @@
         <p:cNvPr id="1" name="">
           <a:extLst>
             <a:ext uri="{FF2B5EF4-FFF2-40B4-BE49-F238E27FC236}">
-              <a16:creationId xmlns:a16="http://schemas.microsoft.com/office/drawing/2014/main" id="{099E537E-A796-B785-204B-6FC35C35BD71}"/>
+              <a16:creationId xmlns:a16="http://schemas.microsoft.com/office/drawing/2014/main" id="{AE615FE5-E8BE-3F95-1F43-3E193F4F93EC}"/>
             </a:ext>
           </a:extLst>
         </p:cNvPr>
@@ -7582,7 +8669,7 @@
           <p:cNvPr id="2" name="Title 1">
             <a:extLst>
               <a:ext uri="{FF2B5EF4-FFF2-40B4-BE49-F238E27FC236}">
-                <a16:creationId xmlns:a16="http://schemas.microsoft.com/office/drawing/2014/main" id="{AFA8BCB4-E432-3E7C-B0B9-D2BA4B055077}"/>
+                <a16:creationId xmlns:a16="http://schemas.microsoft.com/office/drawing/2014/main" id="{76713FEC-397D-FD4B-A53F-455B271D0633}"/>
               </a:ext>
             </a:extLst>
           </p:cNvPr>
@@ -7600,7 +8687,7 @@
           <a:p>
             <a:r>
               <a:rPr lang="en-US" dirty="0"/>
-              <a:t>Connecting to DataWrangling2025 SQL Server through SAS Server (cont.)</a:t>
+              <a:t>Connecting to DataWrangling2025 SQL Server through SAS Server</a:t>
             </a:r>
           </a:p>
         </p:txBody>
@@ -7610,7 +8697,7 @@
           <p:cNvPr id="3" name="Content Placeholder 2">
             <a:extLst>
               <a:ext uri="{FF2B5EF4-FFF2-40B4-BE49-F238E27FC236}">
-                <a16:creationId xmlns:a16="http://schemas.microsoft.com/office/drawing/2014/main" id="{7F3AE4DB-035A-3749-77C9-561C2A4B5D1A}"/>
+                <a16:creationId xmlns:a16="http://schemas.microsoft.com/office/drawing/2014/main" id="{BCB98F0A-3DA1-1B34-0266-D74AE1C09A2E}"/>
               </a:ext>
             </a:extLst>
           </p:cNvPr>
@@ -7638,13 +8725,8 @@
             </a:pPr>
             <a:r>
               <a:rPr lang="en-US" b="1" dirty="0"/>
-              <a:t>Using proc </a:t>
-            </a:r>
-            <a:r>
-              <a:rPr lang="en-US" b="1" dirty="0" err="1"/>
-              <a:t>sql</a:t>
-            </a:r>
-            <a:endParaRPr lang="en-US" b="1" dirty="0"/>
+              <a:t>Using data source name (DSN)</a:t>
+            </a:r>
           </a:p>
           <a:p>
             <a:r>
@@ -7657,7 +8739,7 @@
             </a:r>
             <a:r>
               <a:rPr lang="en-US" dirty="0"/>
-              <a:t> (lines 19-28) in SAS Studio</a:t>
+              <a:t> (lines 13-15) in SAS Studio</a:t>
             </a:r>
           </a:p>
           <a:p>
@@ -7695,10 +8777,10 @@
       </p:sp>
       <p:pic>
         <p:nvPicPr>
-          <p:cNvPr id="6" name="Picture 5">
-            <a:extLst>
-              <a:ext uri="{FF2B5EF4-FFF2-40B4-BE49-F238E27FC236}">
-                <a16:creationId xmlns:a16="http://schemas.microsoft.com/office/drawing/2014/main" id="{232D671F-1BF7-2FE2-96EC-9F3BBBE70B10}"/>
+          <p:cNvPr id="5" name="Picture 4">
+            <a:extLst>
+              <a:ext uri="{FF2B5EF4-FFF2-40B4-BE49-F238E27FC236}">
+                <a16:creationId xmlns:a16="http://schemas.microsoft.com/office/drawing/2014/main" id="{CCD5DB46-F544-B1CE-950D-6021F3FA5F72}"/>
               </a:ext>
             </a:extLst>
           </p:cNvPr>
@@ -7715,18 +8797,66 @@
         </p:blipFill>
         <p:spPr>
           <a:xfrm>
-            <a:off x="6096000" y="2875619"/>
-            <a:ext cx="6004858" cy="2150339"/>
+            <a:off x="6297038" y="3053181"/>
+            <a:ext cx="5792008" cy="1257475"/>
           </a:xfrm>
           <a:prstGeom prst="rect">
             <a:avLst/>
           </a:prstGeom>
         </p:spPr>
       </p:pic>
+      <p:sp>
+        <p:nvSpPr>
+          <p:cNvPr id="8" name="Rectangle: Rounded Corners 7">
+            <a:hlinkClick r:id="rId5" action="ppaction://hlinksldjump"/>
+            <a:extLst>
+              <a:ext uri="{FF2B5EF4-FFF2-40B4-BE49-F238E27FC236}">
+                <a16:creationId xmlns:a16="http://schemas.microsoft.com/office/drawing/2014/main" id="{937CACEC-F80D-99B6-4503-79F51953A82B}"/>
+              </a:ext>
+            </a:extLst>
+          </p:cNvPr>
+          <p:cNvSpPr/>
+          <p:nvPr/>
+        </p:nvSpPr>
+        <p:spPr>
+          <a:xfrm>
+            <a:off x="11226800" y="107950"/>
+            <a:ext cx="812800" cy="317500"/>
+          </a:xfrm>
+          <a:prstGeom prst="roundRect">
+            <a:avLst/>
+          </a:prstGeom>
+        </p:spPr>
+        <p:style>
+          <a:lnRef idx="1">
+            <a:schemeClr val="accent4"/>
+          </a:lnRef>
+          <a:fillRef idx="2">
+            <a:schemeClr val="accent4"/>
+          </a:fillRef>
+          <a:effectRef idx="1">
+            <a:schemeClr val="accent4"/>
+          </a:effectRef>
+          <a:fontRef idx="minor">
+            <a:schemeClr val="dk1"/>
+          </a:fontRef>
+        </p:style>
+        <p:txBody>
+          <a:bodyPr rtlCol="0" anchor="ctr"/>
+          <a:lstStyle/>
+          <a:p>
+            <a:pPr algn="ctr"/>
+            <a:r>
+              <a:rPr lang="en-US" sz="1200" dirty="0"/>
+              <a:t>HOME</a:t>
+            </a:r>
+          </a:p>
+        </p:txBody>
+      </p:sp>
     </p:spTree>
     <p:extLst>
       <p:ext uri="{BB962C8B-B14F-4D97-AF65-F5344CB8AC3E}">
-        <p14:creationId xmlns:p14="http://schemas.microsoft.com/office/powerpoint/2010/main" val="1092146382"/>
+        <p14:creationId xmlns:p14="http://schemas.microsoft.com/office/powerpoint/2010/main" val="2824653451"/>
       </p:ext>
     </p:extLst>
   </p:cSld>
@@ -8364,4 +9494,10 @@
     </a:ext>
   </a:extLst>
 </a:theme>
+</file>
+
+<file path=docMetadata/LabelInfo.xml><?xml version="1.0" encoding="utf-8"?>
+<clbl:labelList xmlns:clbl="http://schemas.microsoft.com/office/2020/mipLabelMetadata">
+  <clbl:label id="{65ce1208-e929-4ec4-be64-9138d78922c0}" enabled="1" method="Standard" siteId="{22340fa8-9226-4871-b677-d3b3e377af72}" contentBits="2" removed="0"/>
+</clbl:labelList>
 </file>
</xml_diff>